<commit_message>
docs: update complete PowerPoint presentation and bundle with judges QA defense slides
</commit_message>
<xml_diff>
--- a/public/LegalMetriX_SIH_Presentation.pptx
+++ b/public/LegalMetriX_SIH_Presentation.pptx
@@ -11,6 +11,12 @@
     <p:sldId id="259" r:id="rId10"/>
     <p:sldId id="260" r:id="rId11"/>
     <p:sldId id="261" r:id="rId12"/>
+    <p:sldId id="262" r:id="rId13"/>
+    <p:sldId id="263" r:id="rId14"/>
+    <p:sldId id="264" r:id="rId15"/>
+    <p:sldId id="265" r:id="rId16"/>
+    <p:sldId id="266" r:id="rId17"/>
+    <p:sldId id="267" r:id="rId18"/>
   </p:sldIdLst>
   <p:sldSz cx="12191695" cy="6858000" type="screen4x3"/>
   <p:notesSz cx="6858000" cy="9144000"/>
@@ -3181,7 +3187,7 @@
         </p:nvSpPr>
         <p:spPr>
           <a:xfrm>
-            <a:off x="914400" y="1828800"/>
+            <a:off x="914400" y="1737360"/>
             <a:ext cx="10058400" cy="4389120"/>
           </a:xfrm>
           <a:prstGeom prst="rect">
@@ -3210,7 +3216,7 @@
               <a:t>• Problem Statement ID -</a:t>
             </a:r>
             <a:r>
-              <a:rPr sz="2000" b="0">
+              <a:rPr sz="2000">
                 <a:solidFill>
                   <a:srgbClr val="2563EB"/>
                 </a:solidFill>
@@ -3235,7 +3241,7 @@
               <a:t>• Problem Statement Title -</a:t>
             </a:r>
             <a:r>
-              <a:rPr sz="2000" b="0">
+              <a:rPr sz="2000">
                 <a:solidFill>
                   <a:srgbClr val="2563EB"/>
                 </a:solidFill>
@@ -3260,7 +3266,7 @@
               <a:t>• Theme -</a:t>
             </a:r>
             <a:r>
-              <a:rPr sz="2000" b="0">
+              <a:rPr sz="2000">
                 <a:solidFill>
                   <a:srgbClr val="2563EB"/>
                 </a:solidFill>
@@ -3285,7 +3291,7 @@
               <a:t>• PS Category -</a:t>
             </a:r>
             <a:r>
-              <a:rPr sz="2000" b="0">
+              <a:rPr sz="2000">
                 <a:solidFill>
                   <a:srgbClr val="2563EB"/>
                 </a:solidFill>
@@ -3310,7 +3316,7 @@
               <a:t>• Team ID -</a:t>
             </a:r>
             <a:r>
-              <a:rPr sz="2000" b="0">
+              <a:rPr sz="2000">
                 <a:solidFill>
                   <a:srgbClr val="2563EB"/>
                 </a:solidFill>
@@ -3335,13 +3341,1135 @@
               <a:t>• Team Name -</a:t>
             </a:r>
             <a:r>
-              <a:rPr sz="2000" b="0">
+              <a:rPr sz="2000">
                 <a:solidFill>
                   <a:srgbClr val="2563EB"/>
                 </a:solidFill>
                 <a:latin typeface="Arial"/>
               </a:rPr>
               <a:t> LegalMetriX</a:t>
+            </a:r>
+          </a:p>
+        </p:txBody>
+      </p:sp>
+    </p:spTree>
+  </p:cSld>
+  <p:clrMapOvr>
+    <a:masterClrMapping/>
+  </p:clrMapOvr>
+</p:sld>
+</file>
+
+<file path=ppt/slides/slide10.xml><?xml version="1.0" encoding="utf-8"?>
+<p:sld xmlns:a="http://schemas.openxmlformats.org/drawingml/2006/main" xmlns:p="http://schemas.openxmlformats.org/presentationml/2006/main" xmlns:r="http://schemas.openxmlformats.org/officeDocument/2006/relationships">
+  <p:cSld>
+    <p:spTree>
+      <p:nvGrpSpPr>
+        <p:cNvPr id="1" name=""/>
+        <p:cNvGrpSpPr/>
+        <p:nvPr/>
+      </p:nvGrpSpPr>
+      <p:grpSpPr/>
+      <p:sp>
+        <p:nvSpPr>
+          <p:cNvPr id="2" name="Oval 1"/>
+          <p:cNvSpPr/>
+          <p:nvPr/>
+        </p:nvSpPr>
+        <p:spPr>
+          <a:xfrm>
+            <a:off x="365760" y="228600"/>
+            <a:ext cx="1371600" cy="502920"/>
+          </a:xfrm>
+          <a:prstGeom prst="ellipse">
+            <a:avLst/>
+          </a:prstGeom>
+          <a:solidFill>
+            <a:srgbClr val="FFFFFF"/>
+          </a:solidFill>
+          <a:ln w="19050">
+            <a:solidFill>
+              <a:srgbClr val="1E3A8A"/>
+            </a:solidFill>
+          </a:ln>
+        </p:spPr>
+        <p:style>
+          <a:lnRef idx="1">
+            <a:schemeClr val="accent1"/>
+          </a:lnRef>
+          <a:fillRef idx="3">
+            <a:schemeClr val="accent1"/>
+          </a:fillRef>
+          <a:effectRef idx="2">
+            <a:schemeClr val="accent1"/>
+          </a:effectRef>
+          <a:fontRef idx="minor">
+            <a:schemeClr val="lt1"/>
+          </a:fontRef>
+        </p:style>
+        <p:txBody>
+          <a:bodyPr rtlCol="0" anchor="ctr"/>
+          <a:lstStyle/>
+          <a:p>
+            <a:pPr algn="ctr">
+              <a:defRPr sz="1100" b="1">
+                <a:solidFill>
+                  <a:srgbClr val="1E3A8A"/>
+                </a:solidFill>
+                <a:latin typeface="Arial"/>
+              </a:defRPr>
+            </a:pPr>
+            <a:r>
+              <a:t>LegalMetriX</a:t>
+            </a:r>
+          </a:p>
+        </p:txBody>
+      </p:sp>
+      <p:sp>
+        <p:nvSpPr>
+          <p:cNvPr id="3" name="TextBox 2"/>
+          <p:cNvSpPr txBox="1"/>
+          <p:nvPr/>
+        </p:nvSpPr>
+        <p:spPr>
+          <a:xfrm>
+            <a:off x="1920240" y="137160"/>
+            <a:ext cx="7772400" cy="685800"/>
+          </a:xfrm>
+          <a:prstGeom prst="rect">
+            <a:avLst/>
+          </a:prstGeom>
+          <a:noFill/>
+        </p:spPr>
+        <p:txBody>
+          <a:bodyPr wrap="none">
+            <a:spAutoFit/>
+          </a:bodyPr>
+          <a:lstStyle/>
+          <a:p>
+            <a:pPr algn="ctr">
+              <a:defRPr sz="1900" b="1">
+                <a:solidFill>
+                  <a:srgbClr val="1E3A8A"/>
+                </a:solidFill>
+                <a:latin typeface="Arial"/>
+              </a:defRPr>
+            </a:pPr>
+            <a:r>
+              <a:t>JUDGES Q&amp;A DEFENSE: EDGE CASES &amp; PACKAGING DEFECTS</a:t>
+            </a:r>
+          </a:p>
+        </p:txBody>
+      </p:sp>
+      <p:sp>
+        <p:nvSpPr>
+          <p:cNvPr id="4" name="TextBox 3"/>
+          <p:cNvSpPr txBox="1"/>
+          <p:nvPr/>
+        </p:nvSpPr>
+        <p:spPr>
+          <a:xfrm>
+            <a:off x="9875520" y="137160"/>
+            <a:ext cx="2011680" cy="685800"/>
+          </a:xfrm>
+          <a:prstGeom prst="rect">
+            <a:avLst/>
+          </a:prstGeom>
+          <a:noFill/>
+        </p:spPr>
+        <p:txBody>
+          <a:bodyPr wrap="none">
+            <a:spAutoFit/>
+          </a:bodyPr>
+          <a:lstStyle/>
+          <a:p>
+            <a:pPr algn="ctr">
+              <a:defRPr sz="1000" b="1">
+                <a:solidFill>
+                  <a:srgbClr val="991B1B"/>
+                </a:solidFill>
+                <a:latin typeface="Arial"/>
+              </a:defRPr>
+            </a:pPr>
+            <a:r>
+              <a:t>JUDGES Q&amp;A</a:t>
+            </a:r>
+            <a:br/>
+            <a:r>
+              <a:t>DEFENSE GUIDE</a:t>
+            </a:r>
+          </a:p>
+        </p:txBody>
+      </p:sp>
+      <p:sp>
+        <p:nvSpPr>
+          <p:cNvPr id="5" name="Rounded Rectangle 4"/>
+          <p:cNvSpPr/>
+          <p:nvPr/>
+        </p:nvSpPr>
+        <p:spPr>
+          <a:xfrm>
+            <a:off x="457200" y="1005840"/>
+            <a:ext cx="11277295" cy="1691640"/>
+          </a:xfrm>
+          <a:prstGeom prst="roundRect">
+            <a:avLst/>
+          </a:prstGeom>
+          <a:solidFill>
+            <a:srgbClr val="EFF6FF"/>
+          </a:solidFill>
+          <a:ln w="12700">
+            <a:solidFill>
+              <a:srgbClr val="2563EB"/>
+            </a:solidFill>
+          </a:ln>
+        </p:spPr>
+        <p:style>
+          <a:lnRef idx="1">
+            <a:schemeClr val="accent1"/>
+          </a:lnRef>
+          <a:fillRef idx="3">
+            <a:schemeClr val="accent1"/>
+          </a:fillRef>
+          <a:effectRef idx="2">
+            <a:schemeClr val="accent1"/>
+          </a:effectRef>
+          <a:fontRef idx="minor">
+            <a:schemeClr val="lt1"/>
+          </a:fontRef>
+        </p:style>
+        <p:txBody>
+          <a:bodyPr rtlCol="0" anchor="ctr" wrap="square"/>
+          <a:lstStyle/>
+          <a:p>
+            <a:pPr algn="ctr">
+              <a:spcAft>
+                <a:spcPts val="300"/>
+              </a:spcAft>
+              <a:defRPr b="1" sz="1100">
+                <a:solidFill>
+                  <a:srgbClr val="1E3A8A"/>
+                </a:solidFill>
+              </a:defRPr>
+            </a:pPr>
+            <a:r>
+              <a:t>Q10: How does the system handle multi-language labels (English + Hindi + Regional)?</a:t>
+            </a:r>
+          </a:p>
+          <a:p>
+            <a:r>
+              <a:rPr b="1" sz="950">
+                <a:solidFill>
+                  <a:srgbClr val="166534"/>
+                </a:solidFill>
+              </a:rPr>
+              <a:t>Winning Answer: </a:t>
+            </a:r>
+            <a:r>
+              <a:rPr sz="900">
+                <a:solidFill>
+                  <a:srgbClr val="1E293B"/>
+                </a:solidFill>
+              </a:rPr>
+              <a:t>Under Rule 9 of PCR 2011, declarations must be in English or Hindi (Devanagari), with optional regional languages. Our OCR model supports Devanagari and Indic scripts, aggregating multi-language bounding boxes and verifying compliance on whichever satisfies the statutory requirement.</a:t>
+            </a:r>
+          </a:p>
+        </p:txBody>
+      </p:sp>
+      <p:sp>
+        <p:nvSpPr>
+          <p:cNvPr id="6" name="Rounded Rectangle 5"/>
+          <p:cNvSpPr/>
+          <p:nvPr/>
+        </p:nvSpPr>
+        <p:spPr>
+          <a:xfrm>
+            <a:off x="457200" y="2834640"/>
+            <a:ext cx="11277295" cy="1691640"/>
+          </a:xfrm>
+          <a:prstGeom prst="roundRect">
+            <a:avLst/>
+          </a:prstGeom>
+          <a:solidFill>
+            <a:srgbClr val="F8FAFC"/>
+          </a:solidFill>
+          <a:ln w="12700">
+            <a:solidFill>
+              <a:srgbClr val="CBD5E1"/>
+            </a:solidFill>
+          </a:ln>
+        </p:spPr>
+        <p:style>
+          <a:lnRef idx="1">
+            <a:schemeClr val="accent1"/>
+          </a:lnRef>
+          <a:fillRef idx="3">
+            <a:schemeClr val="accent1"/>
+          </a:fillRef>
+          <a:effectRef idx="2">
+            <a:schemeClr val="accent1"/>
+          </a:effectRef>
+          <a:fontRef idx="minor">
+            <a:schemeClr val="lt1"/>
+          </a:fontRef>
+        </p:style>
+        <p:txBody>
+          <a:bodyPr rtlCol="0" anchor="ctr" wrap="square"/>
+          <a:lstStyle/>
+          <a:p>
+            <a:pPr algn="ctr">
+              <a:spcAft>
+                <a:spcPts val="300"/>
+              </a:spcAft>
+              <a:defRPr b="1" sz="1100">
+                <a:solidFill>
+                  <a:srgbClr val="1E3A8A"/>
+                </a:solidFill>
+              </a:defRPr>
+            </a:pPr>
+            <a:r>
+              <a:t>Q11: What happens if a package is torn, crumpled, or partially stained?</a:t>
+            </a:r>
+          </a:p>
+          <a:p>
+            <a:r>
+              <a:rPr b="1" sz="950">
+                <a:solidFill>
+                  <a:srgbClr val="166534"/>
+                </a:solidFill>
+              </a:rPr>
+              <a:t>Winning Answer: </a:t>
+            </a:r>
+            <a:r>
+              <a:rPr sz="900">
+                <a:solidFill>
+                  <a:srgbClr val="1E293B"/>
+                </a:solidFill>
+              </a:rPr>
+              <a:t>Confidence Threshold Gate: If character recognition confidence drops below 80% due to tearing or smudges, the AI does not guess missing words. It flags the declaration as 'NEEDS REVIEW — Low Visual Confidence' with an evidence box, prompting a close-up crop or physical caliper review.</a:t>
+            </a:r>
+          </a:p>
+        </p:txBody>
+      </p:sp>
+      <p:sp>
+        <p:nvSpPr>
+          <p:cNvPr id="7" name="Rounded Rectangle 6"/>
+          <p:cNvSpPr/>
+          <p:nvPr/>
+        </p:nvSpPr>
+        <p:spPr>
+          <a:xfrm>
+            <a:off x="457200" y="4663440"/>
+            <a:ext cx="11277295" cy="1691640"/>
+          </a:xfrm>
+          <a:prstGeom prst="roundRect">
+            <a:avLst/>
+          </a:prstGeom>
+          <a:solidFill>
+            <a:srgbClr val="EFF6FF"/>
+          </a:solidFill>
+          <a:ln w="12700">
+            <a:solidFill>
+              <a:srgbClr val="2563EB"/>
+            </a:solidFill>
+          </a:ln>
+        </p:spPr>
+        <p:style>
+          <a:lnRef idx="1">
+            <a:schemeClr val="accent1"/>
+          </a:lnRef>
+          <a:fillRef idx="3">
+            <a:schemeClr val="accent1"/>
+          </a:fillRef>
+          <a:effectRef idx="2">
+            <a:schemeClr val="accent1"/>
+          </a:effectRef>
+          <a:fontRef idx="minor">
+            <a:schemeClr val="lt1"/>
+          </a:fontRef>
+        </p:style>
+        <p:txBody>
+          <a:bodyPr rtlCol="0" anchor="ctr" wrap="square"/>
+          <a:lstStyle/>
+          <a:p>
+            <a:pPr algn="ctr">
+              <a:spcAft>
+                <a:spcPts val="300"/>
+              </a:spcAft>
+              <a:defRPr b="1" sz="1100">
+                <a:solidFill>
+                  <a:srgbClr val="1E3A8A"/>
+                </a:solidFill>
+              </a:defRPr>
+            </a:pPr>
+            <a:r>
+              <a:t>Q12: How do you differentiate Manufacturer, Packer, and Importer addresses?</a:t>
+            </a:r>
+          </a:p>
+          <a:p>
+            <a:r>
+              <a:rPr b="1" sz="950">
+                <a:solidFill>
+                  <a:srgbClr val="166534"/>
+                </a:solidFill>
+              </a:rPr>
+              <a:t>Winning Answer: </a:t>
+            </a:r>
+            <a:r>
+              <a:rPr sz="900">
+                <a:solidFill>
+                  <a:srgbClr val="1E293B"/>
+                </a:solidFill>
+              </a:rPr>
+              <a:t>The AI semantic layer searches for statutory keyword markers ('Mfg by', 'Packed by', 'Imported by') and verifies whether the entity name is accompanied by a complete physical address including postal PIN code, as required under Rule 6(1)(a).</a:t>
+            </a:r>
+          </a:p>
+        </p:txBody>
+      </p:sp>
+    </p:spTree>
+  </p:cSld>
+  <p:clrMapOvr>
+    <a:masterClrMapping/>
+  </p:clrMapOvr>
+</p:sld>
+</file>
+
+<file path=ppt/slides/slide11.xml><?xml version="1.0" encoding="utf-8"?>
+<p:sld xmlns:a="http://schemas.openxmlformats.org/drawingml/2006/main" xmlns:p="http://schemas.openxmlformats.org/presentationml/2006/main" xmlns:r="http://schemas.openxmlformats.org/officeDocument/2006/relationships">
+  <p:cSld>
+    <p:spTree>
+      <p:nvGrpSpPr>
+        <p:cNvPr id="1" name=""/>
+        <p:cNvGrpSpPr/>
+        <p:nvPr/>
+      </p:nvGrpSpPr>
+      <p:grpSpPr/>
+      <p:sp>
+        <p:nvSpPr>
+          <p:cNvPr id="2" name="Oval 1"/>
+          <p:cNvSpPr/>
+          <p:nvPr/>
+        </p:nvSpPr>
+        <p:spPr>
+          <a:xfrm>
+            <a:off x="365760" y="228600"/>
+            <a:ext cx="1371600" cy="502920"/>
+          </a:xfrm>
+          <a:prstGeom prst="ellipse">
+            <a:avLst/>
+          </a:prstGeom>
+          <a:solidFill>
+            <a:srgbClr val="FFFFFF"/>
+          </a:solidFill>
+          <a:ln w="19050">
+            <a:solidFill>
+              <a:srgbClr val="1E3A8A"/>
+            </a:solidFill>
+          </a:ln>
+        </p:spPr>
+        <p:style>
+          <a:lnRef idx="1">
+            <a:schemeClr val="accent1"/>
+          </a:lnRef>
+          <a:fillRef idx="3">
+            <a:schemeClr val="accent1"/>
+          </a:fillRef>
+          <a:effectRef idx="2">
+            <a:schemeClr val="accent1"/>
+          </a:effectRef>
+          <a:fontRef idx="minor">
+            <a:schemeClr val="lt1"/>
+          </a:fontRef>
+        </p:style>
+        <p:txBody>
+          <a:bodyPr rtlCol="0" anchor="ctr"/>
+          <a:lstStyle/>
+          <a:p>
+            <a:pPr algn="ctr">
+              <a:defRPr sz="1100" b="1">
+                <a:solidFill>
+                  <a:srgbClr val="1E3A8A"/>
+                </a:solidFill>
+                <a:latin typeface="Arial"/>
+              </a:defRPr>
+            </a:pPr>
+            <a:r>
+              <a:t>LegalMetriX</a:t>
+            </a:r>
+          </a:p>
+        </p:txBody>
+      </p:sp>
+      <p:sp>
+        <p:nvSpPr>
+          <p:cNvPr id="3" name="TextBox 2"/>
+          <p:cNvSpPr txBox="1"/>
+          <p:nvPr/>
+        </p:nvSpPr>
+        <p:spPr>
+          <a:xfrm>
+            <a:off x="1920240" y="137160"/>
+            <a:ext cx="7772400" cy="685800"/>
+          </a:xfrm>
+          <a:prstGeom prst="rect">
+            <a:avLst/>
+          </a:prstGeom>
+          <a:noFill/>
+        </p:spPr>
+        <p:txBody>
+          <a:bodyPr wrap="none">
+            <a:spAutoFit/>
+          </a:bodyPr>
+          <a:lstStyle/>
+          <a:p>
+            <a:pPr algn="ctr">
+              <a:defRPr sz="1900" b="1">
+                <a:solidFill>
+                  <a:srgbClr val="1E3A8A"/>
+                </a:solidFill>
+                <a:latin typeface="Arial"/>
+              </a:defRPr>
+            </a:pPr>
+            <a:r>
+              <a:t>JUDGES Q&amp;A DEFENSE: E-COMMERCE &amp; COUNTERFEIT DETECTION</a:t>
+            </a:r>
+          </a:p>
+        </p:txBody>
+      </p:sp>
+      <p:sp>
+        <p:nvSpPr>
+          <p:cNvPr id="4" name="TextBox 3"/>
+          <p:cNvSpPr txBox="1"/>
+          <p:nvPr/>
+        </p:nvSpPr>
+        <p:spPr>
+          <a:xfrm>
+            <a:off x="9875520" y="137160"/>
+            <a:ext cx="2011680" cy="685800"/>
+          </a:xfrm>
+          <a:prstGeom prst="rect">
+            <a:avLst/>
+          </a:prstGeom>
+          <a:noFill/>
+        </p:spPr>
+        <p:txBody>
+          <a:bodyPr wrap="none">
+            <a:spAutoFit/>
+          </a:bodyPr>
+          <a:lstStyle/>
+          <a:p>
+            <a:pPr algn="ctr">
+              <a:defRPr sz="1000" b="1">
+                <a:solidFill>
+                  <a:srgbClr val="991B1B"/>
+                </a:solidFill>
+                <a:latin typeface="Arial"/>
+              </a:defRPr>
+            </a:pPr>
+            <a:r>
+              <a:t>JUDGES Q&amp;A</a:t>
+            </a:r>
+            <a:br/>
+            <a:r>
+              <a:t>DEFENSE GUIDE</a:t>
+            </a:r>
+          </a:p>
+        </p:txBody>
+      </p:sp>
+      <p:sp>
+        <p:nvSpPr>
+          <p:cNvPr id="5" name="Rounded Rectangle 4"/>
+          <p:cNvSpPr/>
+          <p:nvPr/>
+        </p:nvSpPr>
+        <p:spPr>
+          <a:xfrm>
+            <a:off x="457200" y="1005840"/>
+            <a:ext cx="11277295" cy="1691640"/>
+          </a:xfrm>
+          <a:prstGeom prst="roundRect">
+            <a:avLst/>
+          </a:prstGeom>
+          <a:solidFill>
+            <a:srgbClr val="EFF6FF"/>
+          </a:solidFill>
+          <a:ln w="12700">
+            <a:solidFill>
+              <a:srgbClr val="2563EB"/>
+            </a:solidFill>
+          </a:ln>
+        </p:spPr>
+        <p:style>
+          <a:lnRef idx="1">
+            <a:schemeClr val="accent1"/>
+          </a:lnRef>
+          <a:fillRef idx="3">
+            <a:schemeClr val="accent1"/>
+          </a:fillRef>
+          <a:effectRef idx="2">
+            <a:schemeClr val="accent1"/>
+          </a:effectRef>
+          <a:fontRef idx="minor">
+            <a:schemeClr val="lt1"/>
+          </a:fontRef>
+        </p:style>
+        <p:txBody>
+          <a:bodyPr rtlCol="0" anchor="ctr" wrap="square"/>
+          <a:lstStyle/>
+          <a:p>
+            <a:pPr algn="ctr">
+              <a:spcAft>
+                <a:spcPts val="300"/>
+              </a:spcAft>
+              <a:defRPr b="1" sz="1100">
+                <a:solidFill>
+                  <a:srgbClr val="1E3A8A"/>
+                </a:solidFill>
+              </a:defRPr>
+            </a:pPr>
+            <a:r>
+              <a:t>Q13: Does LegalMetriX work for e-commerce (Amazon, Flipkart, Blinkit, Zepto)?</a:t>
+            </a:r>
+          </a:p>
+          <a:p>
+            <a:r>
+              <a:rPr b="1" sz="950">
+                <a:solidFill>
+                  <a:srgbClr val="166534"/>
+                </a:solidFill>
+              </a:rPr>
+              <a:t>Winning Answer: </a:t>
+            </a:r>
+            <a:r>
+              <a:rPr sz="900">
+                <a:solidFill>
+                  <a:srgbClr val="1E293B"/>
+                </a:solidFill>
+              </a:rPr>
+              <a:t>Yes! Under Rule 6(10) of PCR 2011, digital marketplace listings must display the exact same mandatory declarations as physical packaging. LegalMetriX can ingest product catalog screenshots or e-commerce API feeds and cross-verify digital declarations against physical warehouse samples.</a:t>
+            </a:r>
+          </a:p>
+        </p:txBody>
+      </p:sp>
+      <p:sp>
+        <p:nvSpPr>
+          <p:cNvPr id="6" name="Rounded Rectangle 5"/>
+          <p:cNvSpPr/>
+          <p:nvPr/>
+        </p:nvSpPr>
+        <p:spPr>
+          <a:xfrm>
+            <a:off x="457200" y="2834640"/>
+            <a:ext cx="11277295" cy="1691640"/>
+          </a:xfrm>
+          <a:prstGeom prst="roundRect">
+            <a:avLst/>
+          </a:prstGeom>
+          <a:solidFill>
+            <a:srgbClr val="F8FAFC"/>
+          </a:solidFill>
+          <a:ln w="12700">
+            <a:solidFill>
+              <a:srgbClr val="CBD5E1"/>
+            </a:solidFill>
+          </a:ln>
+        </p:spPr>
+        <p:style>
+          <a:lnRef idx="1">
+            <a:schemeClr val="accent1"/>
+          </a:lnRef>
+          <a:fillRef idx="3">
+            <a:schemeClr val="accent1"/>
+          </a:fillRef>
+          <a:effectRef idx="2">
+            <a:schemeClr val="accent1"/>
+          </a:effectRef>
+          <a:fontRef idx="minor">
+            <a:schemeClr val="lt1"/>
+          </a:fontRef>
+        </p:style>
+        <p:txBody>
+          <a:bodyPr rtlCol="0" anchor="ctr" wrap="square"/>
+          <a:lstStyle/>
+          <a:p>
+            <a:pPr algn="ctr">
+              <a:spcAft>
+                <a:spcPts val="300"/>
+              </a:spcAft>
+              <a:defRPr b="1" sz="1100">
+                <a:solidFill>
+                  <a:srgbClr val="1E3A8A"/>
+                </a:solidFill>
+              </a:defRPr>
+            </a:pPr>
+            <a:r>
+              <a:t>Q14: How can this platform assist in catching counterfeit commodities?</a:t>
+            </a:r>
+          </a:p>
+          <a:p>
+            <a:r>
+              <a:rPr b="1" sz="950">
+                <a:solidFill>
+                  <a:srgbClr val="166534"/>
+                </a:solidFill>
+              </a:rPr>
+              <a:t>Winning Answer: </a:t>
+            </a:r>
+            <a:r>
+              <a:rPr sz="900">
+                <a:solidFill>
+                  <a:srgbClr val="1E293B"/>
+                </a:solidFill>
+              </a:rPr>
+              <a:t>Counterfeits often have subtle legal metrology flaws: mismatched barcodes, fake FSSAI numbers (invalid checksums or 13-digit instead of 14-digit strings), non-existent PIN codes, and missing consumer helpline emails. LegalMetriX instantly flags these mathematical and statutory inconsistencies.</a:t>
+            </a:r>
+          </a:p>
+        </p:txBody>
+      </p:sp>
+      <p:sp>
+        <p:nvSpPr>
+          <p:cNvPr id="7" name="Rounded Rectangle 6"/>
+          <p:cNvSpPr/>
+          <p:nvPr/>
+        </p:nvSpPr>
+        <p:spPr>
+          <a:xfrm>
+            <a:off x="457200" y="4663440"/>
+            <a:ext cx="11277295" cy="1691640"/>
+          </a:xfrm>
+          <a:prstGeom prst="roundRect">
+            <a:avLst/>
+          </a:prstGeom>
+          <a:solidFill>
+            <a:srgbClr val="EFF6FF"/>
+          </a:solidFill>
+          <a:ln w="12700">
+            <a:solidFill>
+              <a:srgbClr val="2563EB"/>
+            </a:solidFill>
+          </a:ln>
+        </p:spPr>
+        <p:style>
+          <a:lnRef idx="1">
+            <a:schemeClr val="accent1"/>
+          </a:lnRef>
+          <a:fillRef idx="3">
+            <a:schemeClr val="accent1"/>
+          </a:fillRef>
+          <a:effectRef idx="2">
+            <a:schemeClr val="accent1"/>
+          </a:effectRef>
+          <a:fontRef idx="minor">
+            <a:schemeClr val="lt1"/>
+          </a:fontRef>
+        </p:style>
+        <p:txBody>
+          <a:bodyPr rtlCol="0" anchor="ctr" wrap="square"/>
+          <a:lstStyle/>
+          <a:p>
+            <a:pPr algn="ctr">
+              <a:spcAft>
+                <a:spcPts val="300"/>
+              </a:spcAft>
+              <a:defRPr b="1" sz="1100">
+                <a:solidFill>
+                  <a:srgbClr val="1E3A8A"/>
+                </a:solidFill>
+              </a:defRPr>
+            </a:pPr>
+            <a:r>
+              <a:t>Q15: How do you check Unit Sale Price (USP) compliance on multi-piece packs?</a:t>
+            </a:r>
+          </a:p>
+          <a:p>
+            <a:r>
+              <a:rPr b="1" sz="950">
+                <a:solidFill>
+                  <a:srgbClr val="166534"/>
+                </a:solidFill>
+              </a:rPr>
+              <a:t>Winning Answer: </a:t>
+            </a:r>
+            <a:r>
+              <a:rPr sz="900">
+                <a:solidFill>
+                  <a:srgbClr val="1E293B"/>
+                </a:solidFill>
+              </a:rPr>
+              <a:t>Under recent PCR amendments, packages containing more than 1 unit must declare the Unit Sale Price (e.g., 'Rs. 1.50 per g'). Our parser calculates the ratio of declared MRP to Net Quantity and verifies whether the corresponding unit price is legibly displayed alongside the total price.</a:t>
+            </a:r>
+          </a:p>
+        </p:txBody>
+      </p:sp>
+    </p:spTree>
+  </p:cSld>
+  <p:clrMapOvr>
+    <a:masterClrMapping/>
+  </p:clrMapOvr>
+</p:sld>
+</file>
+
+<file path=ppt/slides/slide12.xml><?xml version="1.0" encoding="utf-8"?>
+<p:sld xmlns:a="http://schemas.openxmlformats.org/drawingml/2006/main" xmlns:p="http://schemas.openxmlformats.org/presentationml/2006/main" xmlns:r="http://schemas.openxmlformats.org/officeDocument/2006/relationships">
+  <p:cSld>
+    <p:spTree>
+      <p:nvGrpSpPr>
+        <p:cNvPr id="1" name=""/>
+        <p:cNvGrpSpPr/>
+        <p:nvPr/>
+      </p:nvGrpSpPr>
+      <p:grpSpPr/>
+      <p:sp>
+        <p:nvSpPr>
+          <p:cNvPr id="2" name="Oval 1"/>
+          <p:cNvSpPr/>
+          <p:nvPr/>
+        </p:nvSpPr>
+        <p:spPr>
+          <a:xfrm>
+            <a:off x="365760" y="228600"/>
+            <a:ext cx="1371600" cy="502920"/>
+          </a:xfrm>
+          <a:prstGeom prst="ellipse">
+            <a:avLst/>
+          </a:prstGeom>
+          <a:solidFill>
+            <a:srgbClr val="FFFFFF"/>
+          </a:solidFill>
+          <a:ln w="19050">
+            <a:solidFill>
+              <a:srgbClr val="1E3A8A"/>
+            </a:solidFill>
+          </a:ln>
+        </p:spPr>
+        <p:style>
+          <a:lnRef idx="1">
+            <a:schemeClr val="accent1"/>
+          </a:lnRef>
+          <a:fillRef idx="3">
+            <a:schemeClr val="accent1"/>
+          </a:fillRef>
+          <a:effectRef idx="2">
+            <a:schemeClr val="accent1"/>
+          </a:effectRef>
+          <a:fontRef idx="minor">
+            <a:schemeClr val="lt1"/>
+          </a:fontRef>
+        </p:style>
+        <p:txBody>
+          <a:bodyPr rtlCol="0" anchor="ctr"/>
+          <a:lstStyle/>
+          <a:p>
+            <a:pPr algn="ctr">
+              <a:defRPr sz="1100" b="1">
+                <a:solidFill>
+                  <a:srgbClr val="1E3A8A"/>
+                </a:solidFill>
+                <a:latin typeface="Arial"/>
+              </a:defRPr>
+            </a:pPr>
+            <a:r>
+              <a:t>LegalMetriX</a:t>
+            </a:r>
+          </a:p>
+        </p:txBody>
+      </p:sp>
+      <p:sp>
+        <p:nvSpPr>
+          <p:cNvPr id="3" name="TextBox 2"/>
+          <p:cNvSpPr txBox="1"/>
+          <p:nvPr/>
+        </p:nvSpPr>
+        <p:spPr>
+          <a:xfrm>
+            <a:off x="1920240" y="137160"/>
+            <a:ext cx="7772400" cy="685800"/>
+          </a:xfrm>
+          <a:prstGeom prst="rect">
+            <a:avLst/>
+          </a:prstGeom>
+          <a:noFill/>
+        </p:spPr>
+        <p:txBody>
+          <a:bodyPr wrap="none">
+            <a:spAutoFit/>
+          </a:bodyPr>
+          <a:lstStyle/>
+          <a:p>
+            <a:pPr algn="ctr">
+              <a:defRPr sz="1900" b="1">
+                <a:solidFill>
+                  <a:srgbClr val="1E3A8A"/>
+                </a:solidFill>
+                <a:latin typeface="Arial"/>
+              </a:defRPr>
+            </a:pPr>
+            <a:r>
+              <a:t>JUDGES Q&amp;A DEFENSE: SCALABILITY, OFFLINE &amp; INTEGRATION</a:t>
+            </a:r>
+          </a:p>
+        </p:txBody>
+      </p:sp>
+      <p:sp>
+        <p:nvSpPr>
+          <p:cNvPr id="4" name="TextBox 3"/>
+          <p:cNvSpPr txBox="1"/>
+          <p:nvPr/>
+        </p:nvSpPr>
+        <p:spPr>
+          <a:xfrm>
+            <a:off x="9875520" y="137160"/>
+            <a:ext cx="2011680" cy="685800"/>
+          </a:xfrm>
+          <a:prstGeom prst="rect">
+            <a:avLst/>
+          </a:prstGeom>
+          <a:noFill/>
+        </p:spPr>
+        <p:txBody>
+          <a:bodyPr wrap="none">
+            <a:spAutoFit/>
+          </a:bodyPr>
+          <a:lstStyle/>
+          <a:p>
+            <a:pPr algn="ctr">
+              <a:defRPr sz="1000" b="1">
+                <a:solidFill>
+                  <a:srgbClr val="991B1B"/>
+                </a:solidFill>
+                <a:latin typeface="Arial"/>
+              </a:defRPr>
+            </a:pPr>
+            <a:r>
+              <a:t>JUDGES Q&amp;A</a:t>
+            </a:r>
+            <a:br/>
+            <a:r>
+              <a:t>DEFENSE GUIDE</a:t>
+            </a:r>
+          </a:p>
+        </p:txBody>
+      </p:sp>
+      <p:sp>
+        <p:nvSpPr>
+          <p:cNvPr id="5" name="Rounded Rectangle 4"/>
+          <p:cNvSpPr/>
+          <p:nvPr/>
+        </p:nvSpPr>
+        <p:spPr>
+          <a:xfrm>
+            <a:off x="457200" y="1005840"/>
+            <a:ext cx="11277295" cy="1691640"/>
+          </a:xfrm>
+          <a:prstGeom prst="roundRect">
+            <a:avLst/>
+          </a:prstGeom>
+          <a:solidFill>
+            <a:srgbClr val="EFF6FF"/>
+          </a:solidFill>
+          <a:ln w="12700">
+            <a:solidFill>
+              <a:srgbClr val="2563EB"/>
+            </a:solidFill>
+          </a:ln>
+        </p:spPr>
+        <p:style>
+          <a:lnRef idx="1">
+            <a:schemeClr val="accent1"/>
+          </a:lnRef>
+          <a:fillRef idx="3">
+            <a:schemeClr val="accent1"/>
+          </a:fillRef>
+          <a:effectRef idx="2">
+            <a:schemeClr val="accent1"/>
+          </a:effectRef>
+          <a:fontRef idx="minor">
+            <a:schemeClr val="lt1"/>
+          </a:fontRef>
+        </p:style>
+        <p:txBody>
+          <a:bodyPr rtlCol="0" anchor="ctr" wrap="square"/>
+          <a:lstStyle/>
+          <a:p>
+            <a:pPr algn="ctr">
+              <a:spcAft>
+                <a:spcPts val="300"/>
+              </a:spcAft>
+              <a:defRPr b="1" sz="1100">
+                <a:solidFill>
+                  <a:srgbClr val="1E3A8A"/>
+                </a:solidFill>
+              </a:defRPr>
+            </a:pPr>
+            <a:r>
+              <a:t>Q16: How will inspectors operate in remote rural areas with zero internet connectivity?</a:t>
+            </a:r>
+          </a:p>
+          <a:p>
+            <a:r>
+              <a:rPr b="1" sz="950">
+                <a:solidFill>
+                  <a:srgbClr val="166534"/>
+                </a:solidFill>
+              </a:rPr>
+              <a:t>Winning Answer: </a:t>
+            </a:r>
+            <a:r>
+              <a:rPr sz="900">
+                <a:solidFill>
+                  <a:srgbClr val="1E293B"/>
+                </a:solidFill>
+              </a:rPr>
+              <a:t>LegalMetriX is an Offline-First Progressive Web App (PWA) using Service Workers and IndexedDB. Inspectors can capture samples, run local client checks, and queue inspection dockets completely offline. Background sync uploads pending dossiers once network connectivity is restored.</a:t>
+            </a:r>
+          </a:p>
+        </p:txBody>
+      </p:sp>
+      <p:sp>
+        <p:nvSpPr>
+          <p:cNvPr id="6" name="Rounded Rectangle 5"/>
+          <p:cNvSpPr/>
+          <p:nvPr/>
+        </p:nvSpPr>
+        <p:spPr>
+          <a:xfrm>
+            <a:off x="457200" y="2834640"/>
+            <a:ext cx="11277295" cy="1691640"/>
+          </a:xfrm>
+          <a:prstGeom prst="roundRect">
+            <a:avLst/>
+          </a:prstGeom>
+          <a:solidFill>
+            <a:srgbClr val="F8FAFC"/>
+          </a:solidFill>
+          <a:ln w="12700">
+            <a:solidFill>
+              <a:srgbClr val="CBD5E1"/>
+            </a:solidFill>
+          </a:ln>
+        </p:spPr>
+        <p:style>
+          <a:lnRef idx="1">
+            <a:schemeClr val="accent1"/>
+          </a:lnRef>
+          <a:fillRef idx="3">
+            <a:schemeClr val="accent1"/>
+          </a:fillRef>
+          <a:effectRef idx="2">
+            <a:schemeClr val="accent1"/>
+          </a:effectRef>
+          <a:fontRef idx="minor">
+            <a:schemeClr val="lt1"/>
+          </a:fontRef>
+        </p:style>
+        <p:txBody>
+          <a:bodyPr rtlCol="0" anchor="ctr" wrap="square"/>
+          <a:lstStyle/>
+          <a:p>
+            <a:pPr algn="ctr">
+              <a:spcAft>
+                <a:spcPts val="300"/>
+              </a:spcAft>
+              <a:defRPr b="1" sz="1100">
+                <a:solidFill>
+                  <a:srgbClr val="1E3A8A"/>
+                </a:solidFill>
+              </a:defRPr>
+            </a:pPr>
+            <a:r>
+              <a:t>Q17: How can LegalMetriX integrate with existing portals like INGRAM (NCH 1915)?</a:t>
+            </a:r>
+          </a:p>
+          <a:p>
+            <a:r>
+              <a:rPr b="1" sz="950">
+                <a:solidFill>
+                  <a:srgbClr val="166534"/>
+                </a:solidFill>
+              </a:rPr>
+              <a:t>Winning Answer: </a:t>
+            </a:r>
+            <a:r>
+              <a:rPr sz="900">
+                <a:solidFill>
+                  <a:srgbClr val="1E293B"/>
+                </a:solidFill>
+              </a:rPr>
+              <a:t>Our backend API layer is built on standardized REST JSON microservices (/api/complaints, /api/scans, /api/public/track). It can directly plug into the National Consumer Helpline (INGRAM) for citizen grievance intake and state weights &amp; measures databases for automated license verification.</a:t>
+            </a:r>
+          </a:p>
+        </p:txBody>
+      </p:sp>
+      <p:sp>
+        <p:nvSpPr>
+          <p:cNvPr id="7" name="Rounded Rectangle 6"/>
+          <p:cNvSpPr/>
+          <p:nvPr/>
+        </p:nvSpPr>
+        <p:spPr>
+          <a:xfrm>
+            <a:off x="457200" y="4663440"/>
+            <a:ext cx="11277295" cy="1691640"/>
+          </a:xfrm>
+          <a:prstGeom prst="roundRect">
+            <a:avLst/>
+          </a:prstGeom>
+          <a:solidFill>
+            <a:srgbClr val="EFF6FF"/>
+          </a:solidFill>
+          <a:ln w="12700">
+            <a:solidFill>
+              <a:srgbClr val="2563EB"/>
+            </a:solidFill>
+          </a:ln>
+        </p:spPr>
+        <p:style>
+          <a:lnRef idx="1">
+            <a:schemeClr val="accent1"/>
+          </a:lnRef>
+          <a:fillRef idx="3">
+            <a:schemeClr val="accent1"/>
+          </a:fillRef>
+          <a:effectRef idx="2">
+            <a:schemeClr val="accent1"/>
+          </a:effectRef>
+          <a:fontRef idx="minor">
+            <a:schemeClr val="lt1"/>
+          </a:fontRef>
+        </p:style>
+        <p:txBody>
+          <a:bodyPr rtlCol="0" anchor="ctr" wrap="square"/>
+          <a:lstStyle/>
+          <a:p>
+            <a:pPr algn="ctr">
+              <a:spcAft>
+                <a:spcPts val="300"/>
+              </a:spcAft>
+              <a:defRPr b="1" sz="1100">
+                <a:solidFill>
+                  <a:srgbClr val="1E3A8A"/>
+                </a:solidFill>
+              </a:defRPr>
+            </a:pPr>
+            <a:r>
+              <a:t>Q18: Why is LegalMetriX ready for immediate adoption by State Governments?</a:t>
+            </a:r>
+          </a:p>
+          <a:p>
+            <a:r>
+              <a:rPr b="1" sz="950">
+                <a:solidFill>
+                  <a:srgbClr val="166534"/>
+                </a:solidFill>
+              </a:rPr>
+              <a:t>Winning Answer: </a:t>
+            </a:r>
+            <a:r>
+              <a:rPr sz="900">
+                <a:solidFill>
+                  <a:srgbClr val="1E293B"/>
+                </a:solidFill>
+              </a:rPr>
+              <a:t>Because it is not a prototype or mock design — it is fully built, tested, and live right now at https://legal-metrology-dist-three.vercel.app/. It features zero-install web access, full English/Hindi/Telugu localization, realistic statutory workflows, role-based security, and court-ready PDF reporting.</a:t>
             </a:r>
           </a:p>
         </p:txBody>
@@ -3372,8 +4500,8 @@
         </p:nvSpPr>
         <p:spPr>
           <a:xfrm>
-            <a:off x="365760" y="274320"/>
-            <a:ext cx="1371600" cy="548640"/>
+            <a:off x="365760" y="228600"/>
+            <a:ext cx="1371600" cy="502920"/>
           </a:xfrm>
           <a:prstGeom prst="ellipse">
             <a:avLst/>
@@ -3406,7 +4534,7 @@
           <a:lstStyle/>
           <a:p>
             <a:pPr algn="ctr">
-              <a:defRPr sz="1200" b="1">
+              <a:defRPr sz="1100" b="1">
                 <a:solidFill>
                   <a:srgbClr val="1E3A8A"/>
                 </a:solidFill>
@@ -3427,8 +4555,8 @@
         </p:nvSpPr>
         <p:spPr>
           <a:xfrm>
-            <a:off x="1920240" y="182880"/>
-            <a:ext cx="7772400" cy="731520"/>
+            <a:off x="1920240" y="137160"/>
+            <a:ext cx="7772400" cy="685800"/>
           </a:xfrm>
           <a:prstGeom prst="rect">
             <a:avLst/>
@@ -3442,7 +4570,7 @@
           <a:lstStyle/>
           <a:p>
             <a:pPr algn="ctr">
-              <a:defRPr sz="2000" b="1">
+              <a:defRPr sz="1900" b="1">
                 <a:solidFill>
                   <a:srgbClr val="1E3A8A"/>
                 </a:solidFill>
@@ -3463,8 +4591,8 @@
         </p:nvSpPr>
         <p:spPr>
           <a:xfrm>
-            <a:off x="9875520" y="182880"/>
-            <a:ext cx="2011680" cy="731520"/>
+            <a:off x="9875520" y="137160"/>
+            <a:ext cx="2011680" cy="685800"/>
           </a:xfrm>
           <a:prstGeom prst="rect">
             <a:avLst/>
@@ -3478,7 +4606,7 @@
           <a:lstStyle/>
           <a:p>
             <a:pPr algn="ctr">
-              <a:defRPr sz="1100" b="1">
+              <a:defRPr sz="1000" b="1">
                 <a:solidFill>
                   <a:srgbClr val="1E3A8A"/>
                 </a:solidFill>
@@ -3503,8 +4631,8 @@
         </p:nvSpPr>
         <p:spPr>
           <a:xfrm>
-            <a:off x="457200" y="1097280"/>
-            <a:ext cx="6583680" cy="5303520"/>
+            <a:off x="457200" y="1005840"/>
+            <a:ext cx="6583680" cy="5394960"/>
           </a:xfrm>
           <a:prstGeom prst="rect">
             <a:avLst/>
@@ -3519,9 +4647,9 @@
           <a:p>
             <a:pPr>
               <a:spcAft>
-                <a:spcPts val="400"/>
+                <a:spcPts val="300"/>
               </a:spcAft>
-              <a:defRPr sz="1400" b="1">
+              <a:defRPr sz="1300" b="1">
                 <a:solidFill>
                   <a:srgbClr val="1E3A8A"/>
                 </a:solidFill>
@@ -3534,164 +4662,164 @@
           </a:p>
           <a:p>
             <a:pPr>
+              <a:spcAft>
+                <a:spcPts val="200"/>
+              </a:spcAft>
+              <a:defRPr sz="950">
+                <a:solidFill>
+                  <a:srgbClr val="1E293B"/>
+                </a:solidFill>
+                <a:latin typeface="Arial"/>
+              </a:defRPr>
+            </a:pPr>
+            <a:r>
+              <a:t>• Our system 'LegalMetriX' automates end-to-end Legal Metrology inspection, complaint filing, and verification for packaged commodities.</a:t>
+            </a:r>
+          </a:p>
+          <a:p>
+            <a:pPr>
+              <a:spcAft>
+                <a:spcPts val="200"/>
+              </a:spcAft>
+              <a:defRPr sz="950">
+                <a:solidFill>
+                  <a:srgbClr val="1E293B"/>
+                </a:solidFill>
+                <a:latin typeface="Arial"/>
+              </a:defRPr>
+            </a:pPr>
+            <a:r>
+              <a:t>• Users can upload photos, multi-panel surface views, or continuous 360° rotation videos for automated statutory audit.</a:t>
+            </a:r>
+          </a:p>
+          <a:p>
+            <a:pPr>
+              <a:spcAft>
+                <a:spcPts val="200"/>
+              </a:spcAft>
+              <a:defRPr sz="950">
+                <a:solidFill>
+                  <a:srgbClr val="1E293B"/>
+                </a:solidFill>
+                <a:latin typeface="Arial"/>
+              </a:defRPr>
+            </a:pPr>
+            <a:r>
+              <a:t>• Utilizes dual-pass OCR &amp; Gemini Vision to extract and evaluate all mandatory declarations under Rule 6(1) and Rule 12. Live at: legal-metrology-dist-three.vercel.app</a:t>
+            </a:r>
+          </a:p>
+          <a:p>
+            <a:pPr>
+              <a:spcAft>
+                <a:spcPts val="200"/>
+              </a:spcAft>
+              <a:defRPr sz="950">
+                <a:solidFill>
+                  <a:srgbClr val="1E293B"/>
+                </a:solidFill>
+                <a:latin typeface="Arial"/>
+              </a:defRPr>
+            </a:pPr>
+            <a:r>
+              <a:t>• The platform bridges physical ground seizures with digital court-admissible dossiers, case forwarding, and citizen grievance tracking.</a:t>
+            </a:r>
+          </a:p>
+          <a:p>
+            <a:pPr>
+              <a:spcBef>
+                <a:spcPts val="600"/>
+              </a:spcBef>
               <a:spcAft>
                 <a:spcPts val="300"/>
               </a:spcAft>
-              <a:defRPr sz="1000">
-                <a:solidFill>
-                  <a:srgbClr val="1E293B"/>
+              <a:defRPr sz="1300" b="1">
+                <a:solidFill>
+                  <a:srgbClr val="1E3A8A"/>
                 </a:solidFill>
                 <a:latin typeface="Arial"/>
               </a:defRPr>
             </a:pPr>
             <a:r>
-              <a:t>• Our system 'LegalMetriX' automates end-to-end Legal Metrology inspection, complaint filing, and verification for packaged commodities.</a:t>
+              <a:t>Innovation and Uniqueness of our Idea :</a:t>
             </a:r>
           </a:p>
           <a:p>
             <a:pPr>
               <a:spcAft>
-                <a:spcPts val="300"/>
+                <a:spcPts val="200"/>
               </a:spcAft>
-              <a:defRPr sz="1000">
+            </a:pPr>
+            <a:r>
+              <a:rPr b="1" sz="950">
+                <a:solidFill>
+                  <a:srgbClr val="0F172A"/>
+                </a:solidFill>
+              </a:rPr>
+              <a:t>• 360° Rotational Continuous Video Capture :</a:t>
+            </a:r>
+            <a:r>
+              <a:rPr sz="900">
                 <a:solidFill>
                   <a:srgbClr val="1E293B"/>
                 </a:solidFill>
-                <a:latin typeface="Arial"/>
-              </a:defRPr>
-            </a:pPr>
-            <a:r>
-              <a:t>• Users can upload photos, multi-panel surface views, or continuous 360° rotation videos for automated statutory audit.</a:t>
+              </a:rPr>
+              <a:t> Automatically discards motion blur via Laplacian variance and synthesizes orthogonal sharp keyframes.</a:t>
             </a:r>
           </a:p>
           <a:p>
             <a:pPr>
               <a:spcAft>
-                <a:spcPts val="300"/>
+                <a:spcPts val="200"/>
               </a:spcAft>
-              <a:defRPr sz="1000">
+            </a:pPr>
+            <a:r>
+              <a:rPr b="1" sz="950">
+                <a:solidFill>
+                  <a:srgbClr val="0F172A"/>
+                </a:solidFill>
+              </a:rPr>
+              <a:t>• Strict Anti-Hallucination Guardrail :</a:t>
+            </a:r>
+            <a:r>
+              <a:rPr sz="900">
                 <a:solidFill>
                   <a:srgbClr val="1E293B"/>
                 </a:solidFill>
-                <a:latin typeface="Arial"/>
-              </a:defRPr>
-            </a:pPr>
-            <a:r>
-              <a:t>• Utilizes dual-pass OCR &amp; Gemini Vision to extract and evaluate all mandatory declarations under Rule 6(1) and Rule 12. Live at: legal-metrology-dist-three.vercel.app</a:t>
+              </a:rPr>
+              <a:t> Zero-guessing policy. Smudged or missing text is flagged as 'NEEDS VERIFICATION' rather than false violations.</a:t>
             </a:r>
           </a:p>
           <a:p>
             <a:pPr>
               <a:spcAft>
-                <a:spcPts val="300"/>
+                <a:spcPts val="200"/>
               </a:spcAft>
-              <a:defRPr sz="1000">
+            </a:pPr>
+            <a:r>
+              <a:rPr b="1" sz="950">
+                <a:solidFill>
+                  <a:srgbClr val="0F172A"/>
+                </a:solidFill>
+              </a:rPr>
+              <a:t>• Statutory Human-in-the-Loop Digital Seal :</a:t>
+            </a:r>
+            <a:r>
+              <a:rPr sz="900">
                 <a:solidFill>
                   <a:srgbClr val="1E293B"/>
                 </a:solidFill>
-                <a:latin typeface="Arial"/>
-              </a:defRPr>
-            </a:pPr>
-            <a:r>
-              <a:t>• The platform bridges physical ground seizures with digital court-admissible dossiers, case forwarding, and citizen grievance tracking.</a:t>
-            </a:r>
-          </a:p>
-          <a:p>
-            <a:pPr>
-              <a:spcBef>
-                <a:spcPts val="800"/>
-              </a:spcBef>
-              <a:spcAft>
-                <a:spcPts val="400"/>
-              </a:spcAft>
-              <a:defRPr sz="1400" b="1">
-                <a:solidFill>
-                  <a:srgbClr val="1E3A8A"/>
-                </a:solidFill>
-                <a:latin typeface="Arial"/>
-              </a:defRPr>
-            </a:pPr>
-            <a:r>
-              <a:t>Innovation and Uniqueness of our Idea :</a:t>
+              </a:rPr>
+              <a:t> AI outputs assistive cues; only authorized gazetted officers execute legal determinations with cryptographic hash.</a:t>
             </a:r>
           </a:p>
           <a:p>
             <a:pPr>
               <a:spcAft>
-                <a:spcPts val="300"/>
+                <a:spcPts val="200"/>
               </a:spcAft>
             </a:pPr>
             <a:r>
-              <a:rPr b="1" sz="1000">
-                <a:solidFill>
-                  <a:srgbClr val="0F172A"/>
-                </a:solidFill>
-              </a:rPr>
-              <a:t>• 360° Rotational Continuous Video Capture :</a:t>
-            </a:r>
-            <a:r>
-              <a:rPr sz="950">
-                <a:solidFill>
-                  <a:srgbClr val="1E293B"/>
-                </a:solidFill>
-              </a:rPr>
-              <a:t> Automatically discards motion blur via Laplacian variance and synthesizes orthogonal sharp keyframes.</a:t>
-            </a:r>
-          </a:p>
-          <a:p>
-            <a:pPr>
-              <a:spcAft>
-                <a:spcPts val="300"/>
-              </a:spcAft>
-            </a:pPr>
-            <a:r>
-              <a:rPr b="1" sz="1000">
-                <a:solidFill>
-                  <a:srgbClr val="0F172A"/>
-                </a:solidFill>
-              </a:rPr>
-              <a:t>• Strict Anti-Hallucination Guardrail :</a:t>
-            </a:r>
-            <a:r>
-              <a:rPr sz="950">
-                <a:solidFill>
-                  <a:srgbClr val="1E293B"/>
-                </a:solidFill>
-              </a:rPr>
-              <a:t> Zero-guessing policy. Smudged or missing text is flagged as 'NEEDS VERIFICATION' rather than false violations.</a:t>
-            </a:r>
-          </a:p>
-          <a:p>
-            <a:pPr>
-              <a:spcAft>
-                <a:spcPts val="300"/>
-              </a:spcAft>
-            </a:pPr>
-            <a:r>
-              <a:rPr b="1" sz="1000">
-                <a:solidFill>
-                  <a:srgbClr val="0F172A"/>
-                </a:solidFill>
-              </a:rPr>
-              <a:t>• Statutory Human-in-the-Loop Digital Seal :</a:t>
-            </a:r>
-            <a:r>
-              <a:rPr sz="950">
-                <a:solidFill>
-                  <a:srgbClr val="1E293B"/>
-                </a:solidFill>
-              </a:rPr>
-              <a:t> AI outputs assistive cues; only authorized gazetted officers execute legal determinations with cryptographic hash.</a:t>
-            </a:r>
-          </a:p>
-          <a:p>
-            <a:pPr>
-              <a:spcAft>
-                <a:spcPts val="300"/>
-              </a:spcAft>
-            </a:pPr>
-            <a:r>
-              <a:rPr b="1" sz="1000">
+              <a:rPr b="1" sz="950">
                 <a:solidFill>
                   <a:srgbClr val="0F172A"/>
                 </a:solidFill>
@@ -3699,7 +4827,7 @@
               <a:t>• Sanitized Public Citizen Tracking :</a:t>
             </a:r>
             <a:r>
-              <a:rPr sz="950">
+              <a:rPr sz="900">
                 <a:solidFill>
                   <a:srgbClr val="1E293B"/>
                 </a:solidFill>
@@ -3717,7 +4845,7 @@
         </p:nvSpPr>
         <p:spPr>
           <a:xfrm>
-            <a:off x="7315200" y="1097280"/>
+            <a:off x="7315200" y="914400"/>
             <a:ext cx="4389120" cy="365760"/>
           </a:xfrm>
           <a:prstGeom prst="rect">
@@ -3732,11 +4860,10 @@
           <a:lstStyle/>
           <a:p>
             <a:pPr>
-              <a:defRPr sz="1200" b="1">
+              <a:defRPr b="1" sz="1150">
                 <a:solidFill>
                   <a:srgbClr val="1E3A8A"/>
                 </a:solidFill>
-                <a:latin typeface="Arial"/>
               </a:defRPr>
             </a:pPr>
             <a:r>
@@ -3753,8 +4880,8 @@
         </p:nvSpPr>
         <p:spPr>
           <a:xfrm>
-            <a:off x="7315200" y="1554480"/>
-            <a:ext cx="4389120" cy="594360"/>
+            <a:off x="7315200" y="1371600"/>
+            <a:ext cx="4389120" cy="640080"/>
           </a:xfrm>
           <a:prstGeom prst="roundRect">
             <a:avLst/>
@@ -3794,7 +4921,7 @@
               </a:defRPr>
             </a:pPr>
             <a:r>
-              <a:t>Package Capture</a:t>
+              <a:t>1. Package Capture</a:t>
             </a:r>
           </a:p>
           <a:p>
@@ -3819,8 +4946,8 @@
         </p:nvSpPr>
         <p:spPr>
           <a:xfrm>
-            <a:off x="7315200" y="2286000"/>
-            <a:ext cx="4389120" cy="594360"/>
+            <a:off x="7315200" y="2148840"/>
+            <a:ext cx="4389120" cy="640080"/>
           </a:xfrm>
           <a:prstGeom prst="roundRect">
             <a:avLst/>
@@ -3860,7 +4987,7 @@
               </a:defRPr>
             </a:pPr>
             <a:r>
-              <a:t>Keyframe Selector &amp; Filter</a:t>
+              <a:t>2. Keyframe Selector &amp; Filter</a:t>
             </a:r>
           </a:p>
           <a:p>
@@ -3872,7 +4999,7 @@
               </a:defRPr>
             </a:pPr>
             <a:r>
-              <a:t>Laplacian Blur Filter + CLAHE Contrast Enhancement</a:t>
+              <a:t>Laplacian Blur Filter + CLAHE Contrast</a:t>
             </a:r>
           </a:p>
         </p:txBody>
@@ -3885,8 +5012,8 @@
         </p:nvSpPr>
         <p:spPr>
           <a:xfrm>
-            <a:off x="7315200" y="3017520"/>
-            <a:ext cx="4389120" cy="594360"/>
+            <a:off x="7315200" y="2926080"/>
+            <a:ext cx="4389120" cy="640080"/>
           </a:xfrm>
           <a:prstGeom prst="roundRect">
             <a:avLst/>
@@ -3926,7 +5053,7 @@
               </a:defRPr>
             </a:pPr>
             <a:r>
-              <a:t>Dual-Pass OCR &amp; AI Vision</a:t>
+              <a:t>3. Dual-Pass OCR &amp; AI Vision</a:t>
             </a:r>
           </a:p>
           <a:p>
@@ -3938,7 +5065,7 @@
               </a:defRPr>
             </a:pPr>
             <a:r>
-              <a:t>PaddleOCR Local Text ROI + Gemini Semantic Parsing</a:t>
+              <a:t>PaddleOCR Local Text ROI + Gemini Context</a:t>
             </a:r>
           </a:p>
         </p:txBody>
@@ -3951,8 +5078,8 @@
         </p:nvSpPr>
         <p:spPr>
           <a:xfrm>
-            <a:off x="7315200" y="3749039"/>
-            <a:ext cx="4389120" cy="594360"/>
+            <a:off x="7315200" y="3703320"/>
+            <a:ext cx="4389120" cy="640080"/>
           </a:xfrm>
           <a:prstGeom prst="roundRect">
             <a:avLst/>
@@ -3992,7 +5119,7 @@
               </a:defRPr>
             </a:pPr>
             <a:r>
-              <a:t>Statutory Rule 6 &amp; 12 Engine</a:t>
+              <a:t>4. Statutory Rule 6 &amp; 12 Engine</a:t>
             </a:r>
           </a:p>
           <a:p>
@@ -4004,7 +5131,7 @@
               </a:defRPr>
             </a:pPr>
             <a:r>
-              <a:t>MRP, Net Qty, Mfg/Exp Date, Address, Consumer Care</a:t>
+              <a:t>MRP, Net Qty, Mfg/Exp Date, Address, Care</a:t>
             </a:r>
           </a:p>
         </p:txBody>
@@ -4018,7 +5145,7 @@
         <p:spPr>
           <a:xfrm>
             <a:off x="7315200" y="4480560"/>
-            <a:ext cx="4389120" cy="594360"/>
+            <a:ext cx="4389120" cy="640080"/>
           </a:xfrm>
           <a:prstGeom prst="roundRect">
             <a:avLst/>
@@ -4058,7 +5185,7 @@
               </a:defRPr>
             </a:pPr>
             <a:r>
-              <a:t>8-Stage Complaint / Enquiry</a:t>
+              <a:t>5. 8-Stage Complaint / Enquiry</a:t>
             </a:r>
           </a:p>
           <a:p>
@@ -4083,8 +5210,8 @@
         </p:nvSpPr>
         <p:spPr>
           <a:xfrm>
-            <a:off x="7315200" y="5212080"/>
-            <a:ext cx="4389120" cy="594360"/>
+            <a:off x="7315200" y="5257800"/>
+            <a:ext cx="4389120" cy="640080"/>
           </a:xfrm>
           <a:prstGeom prst="roundRect">
             <a:avLst/>
@@ -4124,7 +5251,7 @@
               </a:defRPr>
             </a:pPr>
             <a:r>
-              <a:t>Official Statutory Sign-Off</a:t>
+              <a:t>6. Official Statutory Sign-Off</a:t>
             </a:r>
           </a:p>
           <a:p>
@@ -4136,7 +5263,7 @@
               </a:defRPr>
             </a:pPr>
             <a:r>
-              <a:t>Digital Signature Seal + Tamper-Proof Audit Trail</a:t>
+              <a:t>Digital Signature Seal (SEAL-LM-DIR-XXXX)</a:t>
             </a:r>
           </a:p>
         </p:txBody>
@@ -4167,8 +5294,8 @@
         </p:nvSpPr>
         <p:spPr>
           <a:xfrm>
-            <a:off x="365760" y="274320"/>
-            <a:ext cx="1371600" cy="548640"/>
+            <a:off x="365760" y="228600"/>
+            <a:ext cx="1371600" cy="502920"/>
           </a:xfrm>
           <a:prstGeom prst="ellipse">
             <a:avLst/>
@@ -4201,7 +5328,7 @@
           <a:lstStyle/>
           <a:p>
             <a:pPr algn="ctr">
-              <a:defRPr sz="1200" b="1">
+              <a:defRPr sz="1100" b="1">
                 <a:solidFill>
                   <a:srgbClr val="1E3A8A"/>
                 </a:solidFill>
@@ -4222,8 +5349,8 @@
         </p:nvSpPr>
         <p:spPr>
           <a:xfrm>
-            <a:off x="1920240" y="182880"/>
-            <a:ext cx="7772400" cy="731520"/>
+            <a:off x="1920240" y="137160"/>
+            <a:ext cx="7772400" cy="685800"/>
           </a:xfrm>
           <a:prstGeom prst="rect">
             <a:avLst/>
@@ -4237,7 +5364,7 @@
           <a:lstStyle/>
           <a:p>
             <a:pPr algn="ctr">
-              <a:defRPr sz="2000" b="1">
+              <a:defRPr sz="1900" b="1">
                 <a:solidFill>
                   <a:srgbClr val="1E3A8A"/>
                 </a:solidFill>
@@ -4258,8 +5385,8 @@
         </p:nvSpPr>
         <p:spPr>
           <a:xfrm>
-            <a:off x="9875520" y="182880"/>
-            <a:ext cx="2011680" cy="731520"/>
+            <a:off x="9875520" y="137160"/>
+            <a:ext cx="2011680" cy="685800"/>
           </a:xfrm>
           <a:prstGeom prst="rect">
             <a:avLst/>
@@ -4273,7 +5400,7 @@
           <a:lstStyle/>
           <a:p>
             <a:pPr algn="ctr">
-              <a:defRPr sz="1100" b="1">
+              <a:defRPr sz="1000" b="1">
                 <a:solidFill>
                   <a:srgbClr val="1E3A8A"/>
                 </a:solidFill>
@@ -4298,8 +5425,8 @@
         </p:nvSpPr>
         <p:spPr>
           <a:xfrm>
-            <a:off x="457200" y="1005840"/>
-            <a:ext cx="6217920" cy="4114800"/>
+            <a:off x="457200" y="914400"/>
+            <a:ext cx="6217920" cy="4206240"/>
           </a:xfrm>
           <a:prstGeom prst="rect">
             <a:avLst/>
@@ -4314,11 +5441,11 @@
           <a:p>
             <a:pPr>
               <a:spcAft>
-                <a:spcPts val="400"/>
+                <a:spcPts val="300"/>
               </a:spcAft>
             </a:pPr>
             <a:r>
-              <a:rPr b="1" sz="1050">
+              <a:rPr b="1" sz="1000">
                 <a:solidFill>
                   <a:srgbClr val="0F172A"/>
                 </a:solidFill>
@@ -4327,7 +5454,7 @@
 </a:t>
             </a:r>
             <a:r>
-              <a:rPr sz="900">
+              <a:rPr sz="850">
                 <a:solidFill>
                   <a:srgbClr val="1E293B"/>
                 </a:solidFill>
@@ -4338,11 +5465,11 @@
           <a:p>
             <a:pPr>
               <a:spcAft>
-                <a:spcPts val="400"/>
+                <a:spcPts val="300"/>
               </a:spcAft>
             </a:pPr>
             <a:r>
-              <a:rPr b="1" sz="1050">
+              <a:rPr b="1" sz="1000">
                 <a:solidFill>
                   <a:srgbClr val="0F172A"/>
                 </a:solidFill>
@@ -4351,7 +5478,7 @@
 </a:t>
             </a:r>
             <a:r>
-              <a:rPr sz="900">
+              <a:rPr sz="850">
                 <a:solidFill>
                   <a:srgbClr val="1E293B"/>
                 </a:solidFill>
@@ -4362,11 +5489,11 @@
           <a:p>
             <a:pPr>
               <a:spcAft>
-                <a:spcPts val="400"/>
+                <a:spcPts val="300"/>
               </a:spcAft>
             </a:pPr>
             <a:r>
-              <a:rPr b="1" sz="1050">
+              <a:rPr b="1" sz="1000">
                 <a:solidFill>
                   <a:srgbClr val="0F172A"/>
                 </a:solidFill>
@@ -4375,7 +5502,7 @@
 </a:t>
             </a:r>
             <a:r>
-              <a:rPr sz="900">
+              <a:rPr sz="850">
                 <a:solidFill>
                   <a:srgbClr val="1E293B"/>
                 </a:solidFill>
@@ -4386,11 +5513,11 @@
           <a:p>
             <a:pPr>
               <a:spcAft>
-                <a:spcPts val="400"/>
+                <a:spcPts val="300"/>
               </a:spcAft>
             </a:pPr>
             <a:r>
-              <a:rPr b="1" sz="1050">
+              <a:rPr b="1" sz="1000">
                 <a:solidFill>
                   <a:srgbClr val="0F172A"/>
                 </a:solidFill>
@@ -4399,7 +5526,7 @@
 </a:t>
             </a:r>
             <a:r>
-              <a:rPr sz="900">
+              <a:rPr sz="850">
                 <a:solidFill>
                   <a:srgbClr val="1E293B"/>
                 </a:solidFill>
@@ -4410,11 +5537,11 @@
           <a:p>
             <a:pPr>
               <a:spcAft>
-                <a:spcPts val="400"/>
+                <a:spcPts val="300"/>
               </a:spcAft>
             </a:pPr>
             <a:r>
-              <a:rPr b="1" sz="1050">
+              <a:rPr b="1" sz="1000">
                 <a:solidFill>
                   <a:srgbClr val="0F172A"/>
                 </a:solidFill>
@@ -4423,7 +5550,7 @@
 </a:t>
             </a:r>
             <a:r>
-              <a:rPr sz="900">
+              <a:rPr sz="850">
                 <a:solidFill>
                   <a:srgbClr val="1E293B"/>
                 </a:solidFill>
@@ -4434,11 +5561,11 @@
           <a:p>
             <a:pPr>
               <a:spcAft>
-                <a:spcPts val="400"/>
+                <a:spcPts val="300"/>
               </a:spcAft>
             </a:pPr>
             <a:r>
-              <a:rPr b="1" sz="1050">
+              <a:rPr b="1" sz="1000">
                 <a:solidFill>
                   <a:srgbClr val="0F172A"/>
                 </a:solidFill>
@@ -4447,7 +5574,7 @@
 </a:t>
             </a:r>
             <a:r>
-              <a:rPr sz="900">
+              <a:rPr sz="850">
                 <a:solidFill>
                   <a:srgbClr val="1E293B"/>
                 </a:solidFill>
@@ -4466,7 +5593,7 @@
         <p:spPr>
           <a:xfrm>
             <a:off x="457200" y="5303520"/>
-            <a:ext cx="6217920" cy="365760"/>
+            <a:ext cx="6217920" cy="274320"/>
           </a:xfrm>
           <a:prstGeom prst="rect">
             <a:avLst/>
@@ -4480,7 +5607,7 @@
           <a:lstStyle/>
           <a:p>
             <a:pPr>
-              <a:defRPr b="1" sz="1100">
+              <a:defRPr b="1" sz="1050">
                 <a:solidFill>
                   <a:srgbClr val="1E3A8A"/>
                 </a:solidFill>
@@ -4500,8 +5627,8 @@
         </p:nvSpPr>
         <p:spPr>
           <a:xfrm>
-            <a:off x="457200" y="5669280"/>
-            <a:ext cx="914400" cy="320040"/>
+            <a:off x="457200" y="5623560"/>
+            <a:ext cx="914400" cy="292608"/>
           </a:xfrm>
           <a:prstGeom prst="roundRect">
             <a:avLst/>
@@ -4534,7 +5661,7 @@
           <a:lstStyle/>
           <a:p>
             <a:pPr algn="ctr">
-              <a:defRPr sz="850" b="1">
+              <a:defRPr sz="800" b="1">
                 <a:solidFill>
                   <a:srgbClr val="1E3A8A"/>
                 </a:solidFill>
@@ -4554,8 +5681,8 @@
         </p:nvSpPr>
         <p:spPr>
           <a:xfrm>
-            <a:off x="1463040" y="5669280"/>
-            <a:ext cx="914400" cy="320040"/>
+            <a:off x="1463040" y="5623560"/>
+            <a:ext cx="914400" cy="292608"/>
           </a:xfrm>
           <a:prstGeom prst="roundRect">
             <a:avLst/>
@@ -4588,7 +5715,7 @@
           <a:lstStyle/>
           <a:p>
             <a:pPr algn="ctr">
-              <a:defRPr sz="850" b="1">
+              <a:defRPr sz="800" b="1">
                 <a:solidFill>
                   <a:srgbClr val="1E3A8A"/>
                 </a:solidFill>
@@ -4608,8 +5735,8 @@
         </p:nvSpPr>
         <p:spPr>
           <a:xfrm>
-            <a:off x="2103120" y="5669280"/>
-            <a:ext cx="914400" cy="320040"/>
+            <a:off x="2103120" y="5623560"/>
+            <a:ext cx="914400" cy="292608"/>
           </a:xfrm>
           <a:prstGeom prst="roundRect">
             <a:avLst/>
@@ -4642,7 +5769,7 @@
           <a:lstStyle/>
           <a:p>
             <a:pPr algn="ctr">
-              <a:defRPr sz="850" b="1">
+              <a:defRPr sz="800" b="1">
                 <a:solidFill>
                   <a:srgbClr val="1E3A8A"/>
                 </a:solidFill>
@@ -4662,8 +5789,8 @@
         </p:nvSpPr>
         <p:spPr>
           <a:xfrm>
-            <a:off x="3200400" y="5669280"/>
-            <a:ext cx="914400" cy="320040"/>
+            <a:off x="3200400" y="5623560"/>
+            <a:ext cx="914400" cy="292608"/>
           </a:xfrm>
           <a:prstGeom prst="roundRect">
             <a:avLst/>
@@ -4696,7 +5823,7 @@
           <a:lstStyle/>
           <a:p>
             <a:pPr algn="ctr">
-              <a:defRPr sz="850" b="1">
+              <a:defRPr sz="800" b="1">
                 <a:solidFill>
                   <a:srgbClr val="1E3A8A"/>
                 </a:solidFill>
@@ -4716,8 +5843,8 @@
         </p:nvSpPr>
         <p:spPr>
           <a:xfrm>
-            <a:off x="4297680" y="5669280"/>
-            <a:ext cx="914400" cy="320040"/>
+            <a:off x="4297680" y="5623560"/>
+            <a:ext cx="914400" cy="292608"/>
           </a:xfrm>
           <a:prstGeom prst="roundRect">
             <a:avLst/>
@@ -4750,7 +5877,7 @@
           <a:lstStyle/>
           <a:p>
             <a:pPr algn="ctr">
-              <a:defRPr sz="850" b="1">
+              <a:defRPr sz="800" b="1">
                 <a:solidFill>
                   <a:srgbClr val="1E3A8A"/>
                 </a:solidFill>
@@ -4770,8 +5897,8 @@
         </p:nvSpPr>
         <p:spPr>
           <a:xfrm>
-            <a:off x="5029200" y="5669280"/>
-            <a:ext cx="914400" cy="320040"/>
+            <a:off x="5029200" y="5623560"/>
+            <a:ext cx="914400" cy="292608"/>
           </a:xfrm>
           <a:prstGeom prst="roundRect">
             <a:avLst/>
@@ -4804,7 +5931,7 @@
           <a:lstStyle/>
           <a:p>
             <a:pPr algn="ctr">
-              <a:defRPr sz="850" b="1">
+              <a:defRPr sz="800" b="1">
                 <a:solidFill>
                   <a:srgbClr val="1E3A8A"/>
                 </a:solidFill>
@@ -4824,8 +5951,8 @@
         </p:nvSpPr>
         <p:spPr>
           <a:xfrm>
-            <a:off x="457200" y="6080760"/>
-            <a:ext cx="1005840" cy="320040"/>
+            <a:off x="457200" y="5989320"/>
+            <a:ext cx="1005840" cy="292608"/>
           </a:xfrm>
           <a:prstGeom prst="roundRect">
             <a:avLst/>
@@ -4858,7 +5985,7 @@
           <a:lstStyle/>
           <a:p>
             <a:pPr algn="ctr">
-              <a:defRPr sz="850" b="1">
+              <a:defRPr sz="800" b="1">
                 <a:solidFill>
                   <a:srgbClr val="1E3A8A"/>
                 </a:solidFill>
@@ -4878,8 +6005,8 @@
         </p:nvSpPr>
         <p:spPr>
           <a:xfrm>
-            <a:off x="1463040" y="6080760"/>
-            <a:ext cx="1005840" cy="320040"/>
+            <a:off x="1463040" y="5989320"/>
+            <a:ext cx="1005840" cy="292608"/>
           </a:xfrm>
           <a:prstGeom prst="roundRect">
             <a:avLst/>
@@ -4912,7 +6039,7 @@
           <a:lstStyle/>
           <a:p>
             <a:pPr algn="ctr">
-              <a:defRPr sz="850" b="1">
+              <a:defRPr sz="800" b="1">
                 <a:solidFill>
                   <a:srgbClr val="1E3A8A"/>
                 </a:solidFill>
@@ -4932,8 +6059,8 @@
         </p:nvSpPr>
         <p:spPr>
           <a:xfrm>
-            <a:off x="2377440" y="6080760"/>
-            <a:ext cx="1005840" cy="320040"/>
+            <a:off x="2377440" y="5989320"/>
+            <a:ext cx="1005840" cy="292608"/>
           </a:xfrm>
           <a:prstGeom prst="roundRect">
             <a:avLst/>
@@ -4966,7 +6093,7 @@
           <a:lstStyle/>
           <a:p>
             <a:pPr algn="ctr">
-              <a:defRPr sz="850" b="1">
+              <a:defRPr sz="800" b="1">
                 <a:solidFill>
                   <a:srgbClr val="1E3A8A"/>
                 </a:solidFill>
@@ -4986,8 +6113,8 @@
         </p:nvSpPr>
         <p:spPr>
           <a:xfrm>
-            <a:off x="3474720" y="6080760"/>
-            <a:ext cx="1005840" cy="320040"/>
+            <a:off x="3474720" y="5989320"/>
+            <a:ext cx="1005840" cy="292608"/>
           </a:xfrm>
           <a:prstGeom prst="roundRect">
             <a:avLst/>
@@ -5020,7 +6147,7 @@
           <a:lstStyle/>
           <a:p>
             <a:pPr algn="ctr">
-              <a:defRPr sz="850" b="1">
+              <a:defRPr sz="800" b="1">
                 <a:solidFill>
                   <a:srgbClr val="1E3A8A"/>
                 </a:solidFill>
@@ -5040,8 +6167,8 @@
         </p:nvSpPr>
         <p:spPr>
           <a:xfrm>
-            <a:off x="4754880" y="6080760"/>
-            <a:ext cx="1005840" cy="320040"/>
+            <a:off x="4754880" y="5989320"/>
+            <a:ext cx="1005840" cy="292608"/>
           </a:xfrm>
           <a:prstGeom prst="roundRect">
             <a:avLst/>
@@ -5074,7 +6201,7 @@
           <a:lstStyle/>
           <a:p>
             <a:pPr algn="ctr">
-              <a:defRPr sz="850" b="1">
+              <a:defRPr sz="800" b="1">
                 <a:solidFill>
                   <a:srgbClr val="1E3A8A"/>
                 </a:solidFill>
@@ -5094,7 +6221,7 @@
         </p:nvSpPr>
         <p:spPr>
           <a:xfrm>
-            <a:off x="7132320" y="1005840"/>
+            <a:off x="7132320" y="914400"/>
             <a:ext cx="4572000" cy="365760"/>
           </a:xfrm>
           <a:prstGeom prst="rect">
@@ -5109,7 +6236,7 @@
           <a:lstStyle/>
           <a:p>
             <a:pPr>
-              <a:defRPr b="1" sz="1200">
+              <a:defRPr b="1" sz="1150">
                 <a:solidFill>
                   <a:srgbClr val="1E3A8A"/>
                 </a:solidFill>
@@ -5129,7 +6256,7 @@
         </p:nvSpPr>
         <p:spPr>
           <a:xfrm>
-            <a:off x="7132320" y="1463040"/>
+            <a:off x="7132320" y="1371600"/>
             <a:ext cx="4572000" cy="640080"/>
           </a:xfrm>
           <a:prstGeom prst="rect">
@@ -5163,7 +6290,7 @@
           <a:lstStyle/>
           <a:p>
             <a:pPr algn="ctr">
-              <a:defRPr b="1" sz="1000">
+              <a:defRPr b="1" sz="950">
                 <a:solidFill>
                   <a:srgbClr val="0F172A"/>
                 </a:solidFill>
@@ -5175,14 +6302,14 @@
           </a:p>
           <a:p>
             <a:pPr algn="ctr">
-              <a:defRPr sz="850">
+              <a:defRPr sz="800">
                 <a:solidFill>
                   <a:srgbClr val="1E293B"/>
                 </a:solidFill>
               </a:defRPr>
             </a:pPr>
             <a:r>
-              <a:t>Camera Sensor Binding + EXIF Geolocation</a:t>
+              <a:t>Camera Sensor Binding + Geolocation</a:t>
             </a:r>
           </a:p>
         </p:txBody>
@@ -5195,7 +6322,7 @@
         </p:nvSpPr>
         <p:spPr>
           <a:xfrm>
-            <a:off x="7132320" y="2286000"/>
+            <a:off x="7132320" y="2148840"/>
             <a:ext cx="4572000" cy="640080"/>
           </a:xfrm>
           <a:prstGeom prst="rect">
@@ -5229,7 +6356,7 @@
           <a:lstStyle/>
           <a:p>
             <a:pPr algn="ctr">
-              <a:defRPr b="1" sz="1000">
+              <a:defRPr b="1" sz="950">
                 <a:solidFill>
                   <a:srgbClr val="0F172A"/>
                 </a:solidFill>
@@ -5241,7 +6368,7 @@
           </a:p>
           <a:p>
             <a:pPr algn="ctr">
-              <a:defRPr sz="850">
+              <a:defRPr sz="800">
                 <a:solidFill>
                   <a:srgbClr val="1E293B"/>
                 </a:solidFill>
@@ -5261,7 +6388,7 @@
         </p:nvSpPr>
         <p:spPr>
           <a:xfrm>
-            <a:off x="7132320" y="3108960"/>
+            <a:off x="7132320" y="2926080"/>
             <a:ext cx="4572000" cy="640080"/>
           </a:xfrm>
           <a:prstGeom prst="rect">
@@ -5295,7 +6422,7 @@
           <a:lstStyle/>
           <a:p>
             <a:pPr algn="ctr">
-              <a:defRPr b="1" sz="1000">
+              <a:defRPr b="1" sz="950">
                 <a:solidFill>
                   <a:srgbClr val="0F172A"/>
                 </a:solidFill>
@@ -5307,14 +6434,14 @@
           </a:p>
           <a:p>
             <a:pPr algn="ctr">
-              <a:defRPr sz="850">
+              <a:defRPr sz="800">
                 <a:solidFill>
                   <a:srgbClr val="1E293B"/>
                 </a:solidFill>
               </a:defRPr>
             </a:pPr>
             <a:r>
-              <a:t>Character Detection &amp; Coordinate Bounding Box</a:t>
+              <a:t>Character Detection &amp; Coordinates</a:t>
             </a:r>
           </a:p>
         </p:txBody>
@@ -5327,7 +6454,7 @@
         </p:nvSpPr>
         <p:spPr>
           <a:xfrm>
-            <a:off x="7132320" y="3931920"/>
+            <a:off x="7132320" y="3703320"/>
             <a:ext cx="4572000" cy="640080"/>
           </a:xfrm>
           <a:prstGeom prst="rect">
@@ -5361,7 +6488,7 @@
           <a:lstStyle/>
           <a:p>
             <a:pPr algn="ctr">
-              <a:defRPr b="1" sz="1000">
+              <a:defRPr b="1" sz="950">
                 <a:solidFill>
                   <a:srgbClr val="0F172A"/>
                 </a:solidFill>
@@ -5373,14 +6500,14 @@
           </a:p>
           <a:p>
             <a:pPr algn="ctr">
-              <a:defRPr sz="850">
+              <a:defRPr sz="800">
                 <a:solidFill>
                   <a:srgbClr val="1E293B"/>
                 </a:solidFill>
               </a:defRPr>
             </a:pPr>
             <a:r>
-              <a:t>Legal Context &amp; Tax Inclusion Evaluation</a:t>
+              <a:t>Legal Context &amp; Tax Inclusion</a:t>
             </a:r>
           </a:p>
         </p:txBody>
@@ -5393,7 +6520,7 @@
         </p:nvSpPr>
         <p:spPr>
           <a:xfrm>
-            <a:off x="7132320" y="4754880"/>
+            <a:off x="7132320" y="4480560"/>
             <a:ext cx="4572000" cy="640080"/>
           </a:xfrm>
           <a:prstGeom prst="rect">
@@ -5427,7 +6554,7 @@
           <a:lstStyle/>
           <a:p>
             <a:pPr algn="ctr">
-              <a:defRPr b="1" sz="1000">
+              <a:defRPr b="1" sz="950">
                 <a:solidFill>
                   <a:srgbClr val="0F172A"/>
                 </a:solidFill>
@@ -5439,7 +6566,7 @@
           </a:p>
           <a:p>
             <a:pPr algn="ctr">
-              <a:defRPr sz="850">
+              <a:defRPr sz="800">
                 <a:solidFill>
                   <a:srgbClr val="1E293B"/>
                 </a:solidFill>
@@ -5459,7 +6586,7 @@
         </p:nvSpPr>
         <p:spPr>
           <a:xfrm>
-            <a:off x="7132320" y="5577840"/>
+            <a:off x="7132320" y="5257800"/>
             <a:ext cx="4572000" cy="640080"/>
           </a:xfrm>
           <a:prstGeom prst="rect">
@@ -5493,7 +6620,7 @@
           <a:lstStyle/>
           <a:p>
             <a:pPr algn="ctr">
-              <a:defRPr b="1" sz="1000">
+              <a:defRPr b="1" sz="950">
                 <a:solidFill>
                   <a:srgbClr val="0F172A"/>
                 </a:solidFill>
@@ -5505,7 +6632,7 @@
           </a:p>
           <a:p>
             <a:pPr algn="ctr">
-              <a:defRPr sz="850">
+              <a:defRPr sz="800">
                 <a:solidFill>
                   <a:srgbClr val="1E293B"/>
                 </a:solidFill>
@@ -5543,8 +6670,8 @@
         </p:nvSpPr>
         <p:spPr>
           <a:xfrm>
-            <a:off x="365760" y="274320"/>
-            <a:ext cx="1371600" cy="548640"/>
+            <a:off x="365760" y="228600"/>
+            <a:ext cx="1371600" cy="502920"/>
           </a:xfrm>
           <a:prstGeom prst="ellipse">
             <a:avLst/>
@@ -5577,7 +6704,7 @@
           <a:lstStyle/>
           <a:p>
             <a:pPr algn="ctr">
-              <a:defRPr sz="1200" b="1">
+              <a:defRPr sz="1100" b="1">
                 <a:solidFill>
                   <a:srgbClr val="1E3A8A"/>
                 </a:solidFill>
@@ -5598,8 +6725,8 @@
         </p:nvSpPr>
         <p:spPr>
           <a:xfrm>
-            <a:off x="1920240" y="182880"/>
-            <a:ext cx="7772400" cy="731520"/>
+            <a:off x="1920240" y="137160"/>
+            <a:ext cx="7772400" cy="685800"/>
           </a:xfrm>
           <a:prstGeom prst="rect">
             <a:avLst/>
@@ -5613,7 +6740,7 @@
           <a:lstStyle/>
           <a:p>
             <a:pPr algn="ctr">
-              <a:defRPr sz="2000" b="1">
+              <a:defRPr sz="1900" b="1">
                 <a:solidFill>
                   <a:srgbClr val="1E3A8A"/>
                 </a:solidFill>
@@ -5634,8 +6761,8 @@
         </p:nvSpPr>
         <p:spPr>
           <a:xfrm>
-            <a:off x="9875520" y="182880"/>
-            <a:ext cx="2011680" cy="731520"/>
+            <a:off x="9875520" y="137160"/>
+            <a:ext cx="2011680" cy="685800"/>
           </a:xfrm>
           <a:prstGeom prst="rect">
             <a:avLst/>
@@ -5649,7 +6776,7 @@
           <a:lstStyle/>
           <a:p>
             <a:pPr algn="ctr">
-              <a:defRPr sz="1100" b="1">
+              <a:defRPr sz="1000" b="1">
                 <a:solidFill>
                   <a:srgbClr val="1E3A8A"/>
                 </a:solidFill>
@@ -5674,7 +6801,7 @@
         </p:nvSpPr>
         <p:spPr>
           <a:xfrm>
-            <a:off x="457200" y="1005840"/>
+            <a:off x="457200" y="914400"/>
             <a:ext cx="6217920" cy="5486400"/>
           </a:xfrm>
           <a:prstGeom prst="rect">
@@ -5692,7 +6819,7 @@
               <a:spcAft>
                 <a:spcPts val="200"/>
               </a:spcAft>
-              <a:defRPr b="1" sz="1300">
+              <a:defRPr b="1" sz="1200">
                 <a:solidFill>
                   <a:srgbClr val="1E3A8A"/>
                 </a:solidFill>
@@ -5709,7 +6836,7 @@
               </a:spcAft>
             </a:pPr>
             <a:r>
-              <a:rPr b="1" sz="950">
+              <a:rPr b="1" sz="900">
                 <a:solidFill>
                   <a:srgbClr val="0F172A"/>
                 </a:solidFill>
@@ -5717,7 +6844,7 @@
               <a:t>Technical Feasibility :</a:t>
             </a:r>
             <a:r>
-              <a:rPr sz="900">
+              <a:rPr sz="850">
                 <a:solidFill>
                   <a:srgbClr val="1E293B"/>
                 </a:solidFill>
@@ -5732,7 +6859,7 @@
               </a:spcAft>
             </a:pPr>
             <a:r>
-              <a:rPr b="1" sz="950">
+              <a:rPr b="1" sz="900">
                 <a:solidFill>
                   <a:srgbClr val="0F172A"/>
                 </a:solidFill>
@@ -5740,7 +6867,7 @@
               <a:t>Data Availability :</a:t>
             </a:r>
             <a:r>
-              <a:rPr sz="900">
+              <a:rPr sz="850">
                 <a:solidFill>
                   <a:srgbClr val="1E293B"/>
                 </a:solidFill>
@@ -5755,7 +6882,7 @@
               </a:spcAft>
             </a:pPr>
             <a:r>
-              <a:rPr b="1" sz="950">
+              <a:rPr b="1" sz="900">
                 <a:solidFill>
                   <a:srgbClr val="0F172A"/>
                 </a:solidFill>
@@ -5763,7 +6890,7 @@
               <a:t>Real-time Performance :</a:t>
             </a:r>
             <a:r>
-              <a:rPr sz="900">
+              <a:rPr sz="850">
                 <a:solidFill>
                   <a:srgbClr val="1E293B"/>
                 </a:solidFill>
@@ -5774,12 +6901,12 @@
           <a:p>
             <a:pPr>
               <a:spcBef>
-                <a:spcPts val="600"/>
+                <a:spcPts val="400"/>
               </a:spcBef>
               <a:spcAft>
                 <a:spcPts val="200"/>
               </a:spcAft>
-              <a:defRPr b="1" sz="1300">
+              <a:defRPr b="1" sz="1200">
                 <a:solidFill>
                   <a:srgbClr val="1E3A8A"/>
                 </a:solidFill>
@@ -5794,7 +6921,7 @@
               <a:spcAft>
                 <a:spcPts val="200"/>
               </a:spcAft>
-              <a:defRPr sz="900">
+              <a:defRPr sz="850">
                 <a:solidFill>
                   <a:srgbClr val="1E293B"/>
                 </a:solidFill>
@@ -5809,7 +6936,7 @@
               <a:spcAft>
                 <a:spcPts val="200"/>
               </a:spcAft>
-              <a:defRPr sz="900">
+              <a:defRPr sz="850">
                 <a:solidFill>
                   <a:srgbClr val="1E293B"/>
                 </a:solidFill>
@@ -5824,7 +6951,7 @@
               <a:spcAft>
                 <a:spcPts val="200"/>
               </a:spcAft>
-              <a:defRPr sz="900">
+              <a:defRPr sz="850">
                 <a:solidFill>
                   <a:srgbClr val="1E293B"/>
                 </a:solidFill>
@@ -5837,12 +6964,12 @@
           <a:p>
             <a:pPr>
               <a:spcBef>
-                <a:spcPts val="600"/>
+                <a:spcPts val="400"/>
               </a:spcBef>
               <a:spcAft>
                 <a:spcPts val="200"/>
               </a:spcAft>
-              <a:defRPr b="1" sz="1300">
+              <a:defRPr b="1" sz="1200">
                 <a:solidFill>
                   <a:srgbClr val="1E3A8A"/>
                 </a:solidFill>
@@ -5859,7 +6986,7 @@
               </a:spcAft>
             </a:pPr>
             <a:r>
-              <a:rPr b="1" sz="900">
+              <a:rPr b="1" sz="850">
                 <a:solidFill>
                   <a:srgbClr val="991B1B"/>
                 </a:solidFill>
@@ -5867,7 +6994,7 @@
               <a:t>Risk 1 : </a:t>
             </a:r>
             <a:r>
-              <a:rPr sz="850">
+              <a:rPr sz="800">
                 <a:solidFill>
                   <a:srgbClr val="1E293B"/>
                 </a:solidFill>
@@ -5876,7 +7003,7 @@
 </a:t>
             </a:r>
             <a:r>
-              <a:rPr b="1" sz="900">
+              <a:rPr b="1" sz="850">
                 <a:solidFill>
                   <a:srgbClr val="166534"/>
                 </a:solidFill>
@@ -5884,7 +7011,7 @@
               <a:t>Solution : </a:t>
             </a:r>
             <a:r>
-              <a:rPr sz="850">
+              <a:rPr sz="800">
                 <a:solidFill>
                   <a:srgbClr val="1E293B"/>
                 </a:solidFill>
@@ -5899,7 +7026,7 @@
               </a:spcAft>
             </a:pPr>
             <a:r>
-              <a:rPr b="1" sz="900">
+              <a:rPr b="1" sz="850">
                 <a:solidFill>
                   <a:srgbClr val="991B1B"/>
                 </a:solidFill>
@@ -5907,7 +7034,7 @@
               <a:t>Risk 2 : </a:t>
             </a:r>
             <a:r>
-              <a:rPr sz="850">
+              <a:rPr sz="800">
                 <a:solidFill>
                   <a:srgbClr val="1E293B"/>
                 </a:solidFill>
@@ -5916,7 +7043,7 @@
 </a:t>
             </a:r>
             <a:r>
-              <a:rPr b="1" sz="900">
+              <a:rPr b="1" sz="850">
                 <a:solidFill>
                   <a:srgbClr val="166534"/>
                 </a:solidFill>
@@ -5924,7 +7051,7 @@
               <a:t>Solution : </a:t>
             </a:r>
             <a:r>
-              <a:rPr sz="850">
+              <a:rPr sz="800">
                 <a:solidFill>
                   <a:srgbClr val="1E293B"/>
                 </a:solidFill>
@@ -5942,7 +7069,7 @@
         </p:nvSpPr>
         <p:spPr>
           <a:xfrm>
-            <a:off x="7132320" y="1005840"/>
+            <a:off x="7132320" y="914400"/>
             <a:ext cx="4572000" cy="365760"/>
           </a:xfrm>
           <a:prstGeom prst="rect">
@@ -5957,7 +7084,7 @@
           <a:lstStyle/>
           <a:p>
             <a:pPr>
-              <a:defRPr b="1" sz="1200">
+              <a:defRPr b="1" sz="1150">
                 <a:solidFill>
                   <a:srgbClr val="1E3A8A"/>
                 </a:solidFill>
@@ -5977,8 +7104,8 @@
         </p:nvSpPr>
         <p:spPr>
           <a:xfrm>
-            <a:off x="7132320" y="1463040"/>
-            <a:ext cx="4572000" cy="1051560"/>
+            <a:off x="7132320" y="1371600"/>
+            <a:ext cx="4572000" cy="1097280"/>
           </a:xfrm>
           <a:prstGeom prst="roundRect">
             <a:avLst/>
@@ -5986,7 +7113,7 @@
           <a:solidFill>
             <a:srgbClr val="DBEAFE"/>
           </a:solidFill>
-          <a:ln w="12700">
+          <a:ln>
             <a:solidFill>
               <a:srgbClr val="CBD5E1"/>
             </a:solidFill>
@@ -6011,7 +7138,7 @@
           <a:lstStyle/>
           <a:p>
             <a:pPr algn="ctr">
-              <a:defRPr b="1" sz="1050">
+              <a:defRPr b="1" sz="1000">
                 <a:solidFill>
                   <a:srgbClr val="1E3A8A"/>
                 </a:solidFill>
@@ -6026,7 +7153,7 @@
               <a:spcBef>
                 <a:spcPts val="200"/>
               </a:spcBef>
-              <a:defRPr sz="850">
+              <a:defRPr sz="800">
                 <a:solidFill>
                   <a:srgbClr val="1E293B"/>
                 </a:solidFill>
@@ -6054,8 +7181,8 @@
         </p:nvSpPr>
         <p:spPr>
           <a:xfrm>
-            <a:off x="7132320" y="2743200"/>
-            <a:ext cx="4572000" cy="1051560"/>
+            <a:off x="7132320" y="2651760"/>
+            <a:ext cx="4572000" cy="1097280"/>
           </a:xfrm>
           <a:prstGeom prst="roundRect">
             <a:avLst/>
@@ -6063,7 +7190,7 @@
           <a:solidFill>
             <a:srgbClr val="FEF08A"/>
           </a:solidFill>
-          <a:ln w="12700">
+          <a:ln>
             <a:solidFill>
               <a:srgbClr val="CBD5E1"/>
             </a:solidFill>
@@ -6088,7 +7215,7 @@
           <a:lstStyle/>
           <a:p>
             <a:pPr algn="ctr">
-              <a:defRPr b="1" sz="1050">
+              <a:defRPr b="1" sz="1000">
                 <a:solidFill>
                   <a:srgbClr val="1E3A8A"/>
                 </a:solidFill>
@@ -6103,7 +7230,7 @@
               <a:spcBef>
                 <a:spcPts val="200"/>
               </a:spcBef>
-              <a:defRPr sz="850">
+              <a:defRPr sz="800">
                 <a:solidFill>
                   <a:srgbClr val="1E293B"/>
                 </a:solidFill>
@@ -6118,7 +7245,7 @@
             </a:r>
             <a:br/>
             <a:r>
-              <a:t>Rule 6 &amp; Rule 12 Validation</a:t>
+              <a:t>Rule 6 &amp; 12 Evaluation</a:t>
             </a:r>
           </a:p>
         </p:txBody>
@@ -6131,8 +7258,8 @@
         </p:nvSpPr>
         <p:spPr>
           <a:xfrm>
-            <a:off x="7132320" y="4023360"/>
-            <a:ext cx="4572000" cy="1051560"/>
+            <a:off x="7132320" y="3931920"/>
+            <a:ext cx="4572000" cy="1097280"/>
           </a:xfrm>
           <a:prstGeom prst="roundRect">
             <a:avLst/>
@@ -6140,7 +7267,7 @@
           <a:solidFill>
             <a:srgbClr val="DCFCE7"/>
           </a:solidFill>
-          <a:ln w="12700">
+          <a:ln>
             <a:solidFill>
               <a:srgbClr val="CBD5E1"/>
             </a:solidFill>
@@ -6165,7 +7292,7 @@
           <a:lstStyle/>
           <a:p>
             <a:pPr algn="ctr">
-              <a:defRPr b="1" sz="1050">
+              <a:defRPr b="1" sz="1000">
                 <a:solidFill>
                   <a:srgbClr val="1E3A8A"/>
                 </a:solidFill>
@@ -6180,7 +7307,7 @@
               <a:spcBef>
                 <a:spcPts val="200"/>
               </a:spcBef>
-              <a:defRPr sz="850">
+              <a:defRPr sz="800">
                 <a:solidFill>
                   <a:srgbClr val="1E293B"/>
                 </a:solidFill>
@@ -6208,8 +7335,8 @@
         </p:nvSpPr>
         <p:spPr>
           <a:xfrm>
-            <a:off x="7132320" y="5303520"/>
-            <a:ext cx="4572000" cy="1051560"/>
+            <a:off x="7132320" y="5212080"/>
+            <a:ext cx="4572000" cy="1097280"/>
           </a:xfrm>
           <a:prstGeom prst="roundRect">
             <a:avLst/>
@@ -6217,7 +7344,7 @@
           <a:solidFill>
             <a:srgbClr val="F3E8FF"/>
           </a:solidFill>
-          <a:ln w="12700">
+          <a:ln>
             <a:solidFill>
               <a:srgbClr val="CBD5E1"/>
             </a:solidFill>
@@ -6242,7 +7369,7 @@
           <a:lstStyle/>
           <a:p>
             <a:pPr algn="ctr">
-              <a:defRPr b="1" sz="1050">
+              <a:defRPr b="1" sz="1000">
                 <a:solidFill>
                   <a:srgbClr val="1E3A8A"/>
                 </a:solidFill>
@@ -6257,7 +7384,7 @@
               <a:spcBef>
                 <a:spcPts val="200"/>
               </a:spcBef>
-              <a:defRPr sz="850">
+              <a:defRPr sz="800">
                 <a:solidFill>
                   <a:srgbClr val="1E293B"/>
                 </a:solidFill>
@@ -6303,8 +7430,8 @@
         </p:nvSpPr>
         <p:spPr>
           <a:xfrm>
-            <a:off x="365760" y="274320"/>
-            <a:ext cx="1371600" cy="548640"/>
+            <a:off x="365760" y="228600"/>
+            <a:ext cx="1371600" cy="502920"/>
           </a:xfrm>
           <a:prstGeom prst="ellipse">
             <a:avLst/>
@@ -6337,7 +7464,7 @@
           <a:lstStyle/>
           <a:p>
             <a:pPr algn="ctr">
-              <a:defRPr sz="1200" b="1">
+              <a:defRPr sz="1100" b="1">
                 <a:solidFill>
                   <a:srgbClr val="1E3A8A"/>
                 </a:solidFill>
@@ -6358,8 +7485,8 @@
         </p:nvSpPr>
         <p:spPr>
           <a:xfrm>
-            <a:off x="1920240" y="182880"/>
-            <a:ext cx="7772400" cy="731520"/>
+            <a:off x="1920240" y="137160"/>
+            <a:ext cx="7772400" cy="685800"/>
           </a:xfrm>
           <a:prstGeom prst="rect">
             <a:avLst/>
@@ -6373,7 +7500,7 @@
           <a:lstStyle/>
           <a:p>
             <a:pPr algn="ctr">
-              <a:defRPr sz="2000" b="1">
+              <a:defRPr sz="1900" b="1">
                 <a:solidFill>
                   <a:srgbClr val="1E3A8A"/>
                 </a:solidFill>
@@ -6394,8 +7521,8 @@
         </p:nvSpPr>
         <p:spPr>
           <a:xfrm>
-            <a:off x="9875520" y="182880"/>
-            <a:ext cx="2011680" cy="731520"/>
+            <a:off x="9875520" y="137160"/>
+            <a:ext cx="2011680" cy="685800"/>
           </a:xfrm>
           <a:prstGeom prst="rect">
             <a:avLst/>
@@ -6409,7 +7536,7 @@
           <a:lstStyle/>
           <a:p>
             <a:pPr algn="ctr">
-              <a:defRPr sz="1100" b="1">
+              <a:defRPr sz="1000" b="1">
                 <a:solidFill>
                   <a:srgbClr val="1E3A8A"/>
                 </a:solidFill>
@@ -6434,7 +7561,7 @@
         </p:nvSpPr>
         <p:spPr>
           <a:xfrm>
-            <a:off x="457200" y="1005840"/>
+            <a:off x="457200" y="914400"/>
             <a:ext cx="6217920" cy="2926080"/>
           </a:xfrm>
           <a:prstGeom prst="rect">
@@ -6452,7 +7579,7 @@
               <a:spcAft>
                 <a:spcPts val="200"/>
               </a:spcAft>
-              <a:defRPr b="1" sz="1300">
+              <a:defRPr b="1" sz="1200">
                 <a:solidFill>
                   <a:srgbClr val="1E3A8A"/>
                 </a:solidFill>
@@ -6465,9 +7592,9 @@
           <a:p>
             <a:pPr>
               <a:spcAft>
-                <a:spcPts val="200"/>
+                <a:spcPts val="100"/>
               </a:spcAft>
-              <a:defRPr sz="900">
+              <a:defRPr sz="850">
                 <a:solidFill>
                   <a:srgbClr val="1E293B"/>
                 </a:solidFill>
@@ -6480,9 +7607,9 @@
           <a:p>
             <a:pPr>
               <a:spcAft>
-                <a:spcPts val="200"/>
+                <a:spcPts val="100"/>
               </a:spcAft>
-              <a:defRPr sz="900">
+              <a:defRPr sz="850">
                 <a:solidFill>
                   <a:srgbClr val="1E293B"/>
                 </a:solidFill>
@@ -6495,9 +7622,9 @@
           <a:p>
             <a:pPr>
               <a:spcAft>
-                <a:spcPts val="200"/>
+                <a:spcPts val="100"/>
               </a:spcAft>
-              <a:defRPr sz="900">
+              <a:defRPr sz="850">
                 <a:solidFill>
                   <a:srgbClr val="1E293B"/>
                 </a:solidFill>
@@ -6510,9 +7637,9 @@
           <a:p>
             <a:pPr>
               <a:spcAft>
-                <a:spcPts val="200"/>
+                <a:spcPts val="100"/>
               </a:spcAft>
-              <a:defRPr sz="900">
+              <a:defRPr sz="850">
                 <a:solidFill>
                   <a:srgbClr val="1E293B"/>
                 </a:solidFill>
@@ -6525,12 +7652,12 @@
           <a:p>
             <a:pPr>
               <a:spcBef>
-                <a:spcPts val="400"/>
+                <a:spcPts val="300"/>
               </a:spcBef>
               <a:spcAft>
                 <a:spcPts val="200"/>
               </a:spcAft>
-              <a:defRPr b="1" sz="1300">
+              <a:defRPr b="1" sz="1200">
                 <a:solidFill>
                   <a:srgbClr val="1E3A8A"/>
                 </a:solidFill>
@@ -6543,9 +7670,9 @@
           <a:p>
             <a:pPr>
               <a:spcAft>
-                <a:spcPts val="200"/>
+                <a:spcPts val="100"/>
               </a:spcAft>
-              <a:defRPr sz="900">
+              <a:defRPr sz="850">
                 <a:solidFill>
                   <a:srgbClr val="1E293B"/>
                 </a:solidFill>
@@ -6558,9 +7685,9 @@
           <a:p>
             <a:pPr>
               <a:spcAft>
-                <a:spcPts val="200"/>
+                <a:spcPts val="100"/>
               </a:spcAft>
-              <a:defRPr sz="900">
+              <a:defRPr sz="850">
                 <a:solidFill>
                   <a:srgbClr val="1E293B"/>
                 </a:solidFill>
@@ -6573,9 +7700,9 @@
           <a:p>
             <a:pPr>
               <a:spcAft>
-                <a:spcPts val="200"/>
+                <a:spcPts val="100"/>
               </a:spcAft>
-              <a:defRPr sz="900">
+              <a:defRPr sz="850">
                 <a:solidFill>
                   <a:srgbClr val="1E293B"/>
                 </a:solidFill>
@@ -6588,9 +7715,9 @@
           <a:p>
             <a:pPr>
               <a:spcAft>
-                <a:spcPts val="200"/>
+                <a:spcPts val="100"/>
               </a:spcAft>
-              <a:defRPr sz="900">
+              <a:defRPr sz="850">
                 <a:solidFill>
                   <a:srgbClr val="1E293B"/>
                 </a:solidFill>
@@ -6598,56 +7725,21 @@
             </a:pPr>
             <a:r>
               <a:t>• Zero-Downtime Offline Functionality in remote rural mandis.</a:t>
-            </a:r>
-          </a:p>
-        </p:txBody>
-      </p:sp>
-      <p:sp>
-        <p:nvSpPr>
-          <p:cNvPr id="6" name="TextBox 5"/>
-          <p:cNvSpPr txBox="1"/>
-          <p:nvPr/>
-        </p:nvSpPr>
-        <p:spPr>
-          <a:xfrm>
-            <a:off x="457200" y="4297680"/>
-            <a:ext cx="6217920" cy="365760"/>
-          </a:xfrm>
-          <a:prstGeom prst="rect">
-            <a:avLst/>
-          </a:prstGeom>
-          <a:noFill/>
-        </p:spPr>
-        <p:txBody>
-          <a:bodyPr wrap="none">
-            <a:spAutoFit/>
-          </a:bodyPr>
-          <a:lstStyle/>
-          <a:p>
-            <a:pPr>
-              <a:defRPr b="1" sz="1100">
-                <a:solidFill>
-                  <a:srgbClr val="1E3A8A"/>
-                </a:solidFill>
-              </a:defRPr>
-            </a:pPr>
-            <a:r>
-              <a:t>Performance &amp; Efficiency Benchmarks :</a:t>
             </a:r>
           </a:p>
         </p:txBody>
       </p:sp>
       <p:graphicFrame>
         <p:nvGraphicFramePr>
-          <p:cNvPr id="7" name="Table 6"/>
+          <p:cNvPr id="6" name="Table 5"/>
           <p:cNvGraphicFramePr>
             <a:graphicFrameLocks noGrp="1"/>
           </p:cNvGraphicFramePr>
           <p:nvPr/>
         </p:nvGraphicFramePr>
         <p:xfrm>
-          <a:off x="457200" y="4663440"/>
-          <a:ext cx="6217920" cy="1645920"/>
+          <a:off x="457200" y="4480560"/>
+          <a:ext cx="6217920" cy="1737360"/>
         </p:xfrm>
         <a:graphic>
           <a:graphicData uri="http://schemas.openxmlformats.org/drawingml/2006/table">
@@ -6660,14 +7752,14 @@
                 <a:gridCol w="1920240"/>
                 <a:gridCol w="1920240"/>
               </a:tblGrid>
-              <a:tr h="411480">
+              <a:tr h="434340">
                 <a:tc>
                   <a:txBody>
                     <a:bodyPr/>
                     <a:lstStyle/>
                     <a:p>
                       <a:pPr>
-                        <a:defRPr sz="850" b="1">
+                        <a:defRPr sz="800" b="1">
                           <a:solidFill>
                             <a:srgbClr val="FFFFFF"/>
                           </a:solidFill>
@@ -6690,7 +7782,7 @@
                     <a:lstStyle/>
                     <a:p>
                       <a:pPr>
-                        <a:defRPr sz="850" b="1">
+                        <a:defRPr sz="800" b="1">
                           <a:solidFill>
                             <a:srgbClr val="FFFFFF"/>
                           </a:solidFill>
@@ -6713,7 +7805,7 @@
                     <a:lstStyle/>
                     <a:p>
                       <a:pPr>
-                        <a:defRPr sz="850" b="1">
+                        <a:defRPr sz="800" b="1">
                           <a:solidFill>
                             <a:srgbClr val="FFFFFF"/>
                           </a:solidFill>
@@ -6731,14 +7823,14 @@
                   </a:tcPr>
                 </a:tc>
               </a:tr>
-              <a:tr h="411480">
+              <a:tr h="434340">
                 <a:tc>
                   <a:txBody>
                     <a:bodyPr/>
                     <a:lstStyle/>
                     <a:p>
                       <a:pPr>
-                        <a:defRPr sz="850">
+                        <a:defRPr sz="800">
                           <a:solidFill>
                             <a:srgbClr val="1E293B"/>
                           </a:solidFill>
@@ -6761,7 +7853,7 @@
                     <a:lstStyle/>
                     <a:p>
                       <a:pPr>
-                        <a:defRPr sz="850">
+                        <a:defRPr sz="800">
                           <a:solidFill>
                             <a:srgbClr val="1E293B"/>
                           </a:solidFill>
@@ -6784,7 +7876,7 @@
                     <a:lstStyle/>
                     <a:p>
                       <a:pPr>
-                        <a:defRPr sz="850">
+                        <a:defRPr sz="800">
                           <a:solidFill>
                             <a:srgbClr val="1E293B"/>
                           </a:solidFill>
@@ -6802,14 +7894,14 @@
                   </a:tcPr>
                 </a:tc>
               </a:tr>
-              <a:tr h="411480">
+              <a:tr h="434340">
                 <a:tc>
                   <a:txBody>
                     <a:bodyPr/>
                     <a:lstStyle/>
                     <a:p>
                       <a:pPr>
-                        <a:defRPr sz="850">
+                        <a:defRPr sz="800">
                           <a:solidFill>
                             <a:srgbClr val="1E293B"/>
                           </a:solidFill>
@@ -6832,7 +7924,7 @@
                     <a:lstStyle/>
                     <a:p>
                       <a:pPr>
-                        <a:defRPr sz="850">
+                        <a:defRPr sz="800">
                           <a:solidFill>
                             <a:srgbClr val="1E293B"/>
                           </a:solidFill>
@@ -6855,7 +7947,7 @@
                     <a:lstStyle/>
                     <a:p>
                       <a:pPr>
-                        <a:defRPr sz="850">
+                        <a:defRPr sz="800">
                           <a:solidFill>
                             <a:srgbClr val="1E293B"/>
                           </a:solidFill>
@@ -6873,14 +7965,14 @@
                   </a:tcPr>
                 </a:tc>
               </a:tr>
-              <a:tr h="411480">
+              <a:tr h="434340">
                 <a:tc>
                   <a:txBody>
                     <a:bodyPr/>
                     <a:lstStyle/>
                     <a:p>
                       <a:pPr>
-                        <a:defRPr sz="850">
+                        <a:defRPr sz="800">
                           <a:solidFill>
                             <a:srgbClr val="1E293B"/>
                           </a:solidFill>
@@ -6903,7 +7995,7 @@
                     <a:lstStyle/>
                     <a:p>
                       <a:pPr>
-                        <a:defRPr sz="850">
+                        <a:defRPr sz="800">
                           <a:solidFill>
                             <a:srgbClr val="1E293B"/>
                           </a:solidFill>
@@ -6926,7 +8018,7 @@
                     <a:lstStyle/>
                     <a:p>
                       <a:pPr>
-                        <a:defRPr sz="850">
+                        <a:defRPr sz="800">
                           <a:solidFill>
                             <a:srgbClr val="1E293B"/>
                           </a:solidFill>
@@ -6950,13 +8042,13 @@
       </p:graphicFrame>
       <p:sp>
         <p:nvSpPr>
-          <p:cNvPr id="8" name="TextBox 7"/>
+          <p:cNvPr id="7" name="TextBox 6"/>
           <p:cNvSpPr txBox="1"/>
           <p:nvPr/>
         </p:nvSpPr>
         <p:spPr>
           <a:xfrm>
-            <a:off x="7132320" y="1005840"/>
+            <a:off x="7132320" y="914400"/>
             <a:ext cx="4572000" cy="365760"/>
           </a:xfrm>
           <a:prstGeom prst="rect">
@@ -6971,7 +8063,7 @@
           <a:lstStyle/>
           <a:p>
             <a:pPr>
-              <a:defRPr b="1" sz="1200">
+              <a:defRPr b="1" sz="1150">
                 <a:solidFill>
                   <a:srgbClr val="1E3A8A"/>
                 </a:solidFill>
@@ -6985,13 +8077,13 @@
       </p:sp>
       <p:sp>
         <p:nvSpPr>
-          <p:cNvPr id="9" name="Rounded Rectangle 8"/>
+          <p:cNvPr id="8" name="Rounded Rectangle 7"/>
           <p:cNvSpPr/>
           <p:nvPr/>
         </p:nvSpPr>
         <p:spPr>
           <a:xfrm>
-            <a:off x="7132320" y="1463040"/>
+            <a:off x="7132320" y="1371600"/>
             <a:ext cx="4572000" cy="1097280"/>
           </a:xfrm>
           <a:prstGeom prst="roundRect">
@@ -7025,7 +8117,7 @@
           <a:lstStyle/>
           <a:p>
             <a:pPr algn="ctr">
-              <a:defRPr b="1" sz="1100">
+              <a:defRPr b="1" sz="1050">
                 <a:solidFill>
                   <a:srgbClr val="1E3A8A"/>
                 </a:solidFill>
@@ -7038,9 +8130,9 @@
           <a:p>
             <a:pPr>
               <a:spcBef>
-                <a:spcPts val="300"/>
+                <a:spcPts val="200"/>
               </a:spcBef>
-              <a:defRPr sz="850">
+              <a:defRPr sz="800">
                 <a:solidFill>
                   <a:srgbClr val="1E293B"/>
                 </a:solidFill>
@@ -7054,13 +8146,13 @@
       </p:sp>
       <p:sp>
         <p:nvSpPr>
-          <p:cNvPr id="10" name="Rounded Rectangle 9"/>
+          <p:cNvPr id="9" name="Rounded Rectangle 8"/>
           <p:cNvSpPr/>
           <p:nvPr/>
         </p:nvSpPr>
         <p:spPr>
           <a:xfrm>
-            <a:off x="7132320" y="2697480"/>
+            <a:off x="7132320" y="2606040"/>
             <a:ext cx="4572000" cy="1097280"/>
           </a:xfrm>
           <a:prstGeom prst="roundRect">
@@ -7094,7 +8186,7 @@
           <a:lstStyle/>
           <a:p>
             <a:pPr algn="ctr">
-              <a:defRPr b="1" sz="1100">
+              <a:defRPr b="1" sz="1050">
                 <a:solidFill>
                   <a:srgbClr val="1E3A8A"/>
                 </a:solidFill>
@@ -7107,29 +8199,29 @@
           <a:p>
             <a:pPr>
               <a:spcBef>
-                <a:spcPts val="300"/>
+                <a:spcPts val="200"/>
               </a:spcBef>
-              <a:defRPr sz="850">
+              <a:defRPr sz="800">
                 <a:solidFill>
                   <a:srgbClr val="1E293B"/>
                 </a:solidFill>
               </a:defRPr>
             </a:pPr>
             <a:r>
-              <a:t>Full rule evaluation across MRP, Net Quantity, Mfg Date, Expiry, Address, and Care.</a:t>
-            </a:r>
-          </a:p>
-        </p:txBody>
-      </p:sp>
-      <p:sp>
-        <p:nvSpPr>
-          <p:cNvPr id="11" name="Rounded Rectangle 10"/>
+              <a:t>Full evaluation across MRP, Net Quantity, Mfg Date, Expiry, Address, and Care.</a:t>
+            </a:r>
+          </a:p>
+        </p:txBody>
+      </p:sp>
+      <p:sp>
+        <p:nvSpPr>
+          <p:cNvPr id="10" name="Rounded Rectangle 9"/>
           <p:cNvSpPr/>
           <p:nvPr/>
         </p:nvSpPr>
         <p:spPr>
           <a:xfrm>
-            <a:off x="7132320" y="3931920"/>
+            <a:off x="7132320" y="3840480"/>
             <a:ext cx="4572000" cy="1097280"/>
           </a:xfrm>
           <a:prstGeom prst="roundRect">
@@ -7163,7 +8255,7 @@
           <a:lstStyle/>
           <a:p>
             <a:pPr algn="ctr">
-              <a:defRPr b="1" sz="1100">
+              <a:defRPr b="1" sz="1050">
                 <a:solidFill>
                   <a:srgbClr val="1E3A8A"/>
                 </a:solidFill>
@@ -7176,9 +8268,9 @@
           <a:p>
             <a:pPr>
               <a:spcBef>
-                <a:spcPts val="300"/>
+                <a:spcPts val="200"/>
               </a:spcBef>
-              <a:defRPr sz="850">
+              <a:defRPr sz="800">
                 <a:solidFill>
                   <a:srgbClr val="1E293B"/>
                 </a:solidFill>
@@ -7192,13 +8284,13 @@
       </p:sp>
       <p:sp>
         <p:nvSpPr>
-          <p:cNvPr id="12" name="Rounded Rectangle 11"/>
+          <p:cNvPr id="11" name="Rounded Rectangle 10"/>
           <p:cNvSpPr/>
           <p:nvPr/>
         </p:nvSpPr>
         <p:spPr>
           <a:xfrm>
-            <a:off x="7132320" y="5166360"/>
+            <a:off x="7132320" y="5074920"/>
             <a:ext cx="4572000" cy="1097280"/>
           </a:xfrm>
           <a:prstGeom prst="roundRect">
@@ -7232,7 +8324,7 @@
           <a:lstStyle/>
           <a:p>
             <a:pPr algn="ctr">
-              <a:defRPr b="1" sz="1100">
+              <a:defRPr b="1" sz="1050">
                 <a:solidFill>
                   <a:srgbClr val="1E3A8A"/>
                 </a:solidFill>
@@ -7245,16 +8337,16 @@
           <a:p>
             <a:pPr>
               <a:spcBef>
-                <a:spcPts val="300"/>
+                <a:spcPts val="200"/>
               </a:spcBef>
-              <a:defRPr sz="850">
+              <a:defRPr sz="800">
                 <a:solidFill>
                   <a:srgbClr val="1E293B"/>
                 </a:solidFill>
               </a:defRPr>
             </a:pPr>
             <a:r>
-              <a:t>IndexedDB background queue guarantees zero loss of market inspection records.</a:t>
+              <a:t>IndexedDB background queue guarantees zero loss of market records.</a:t>
             </a:r>
           </a:p>
         </p:txBody>
@@ -7285,8 +8377,8 @@
         </p:nvSpPr>
         <p:spPr>
           <a:xfrm>
-            <a:off x="365760" y="274320"/>
-            <a:ext cx="1371600" cy="548640"/>
+            <a:off x="365760" y="228600"/>
+            <a:ext cx="1371600" cy="502920"/>
           </a:xfrm>
           <a:prstGeom prst="ellipse">
             <a:avLst/>
@@ -7319,7 +8411,7 @@
           <a:lstStyle/>
           <a:p>
             <a:pPr algn="ctr">
-              <a:defRPr sz="1200" b="1">
+              <a:defRPr sz="1100" b="1">
                 <a:solidFill>
                   <a:srgbClr val="1E3A8A"/>
                 </a:solidFill>
@@ -7340,8 +8432,8 @@
         </p:nvSpPr>
         <p:spPr>
           <a:xfrm>
-            <a:off x="1920240" y="182880"/>
-            <a:ext cx="7772400" cy="731520"/>
+            <a:off x="1920240" y="137160"/>
+            <a:ext cx="7772400" cy="685800"/>
           </a:xfrm>
           <a:prstGeom prst="rect">
             <a:avLst/>
@@ -7355,7 +8447,7 @@
           <a:lstStyle/>
           <a:p>
             <a:pPr algn="ctr">
-              <a:defRPr sz="2000" b="1">
+              <a:defRPr sz="1900" b="1">
                 <a:solidFill>
                   <a:srgbClr val="1E3A8A"/>
                 </a:solidFill>
@@ -7376,8 +8468,8 @@
         </p:nvSpPr>
         <p:spPr>
           <a:xfrm>
-            <a:off x="9875520" y="182880"/>
-            <a:ext cx="2011680" cy="731520"/>
+            <a:off x="9875520" y="137160"/>
+            <a:ext cx="2011680" cy="685800"/>
           </a:xfrm>
           <a:prstGeom prst="rect">
             <a:avLst/>
@@ -7391,7 +8483,7 @@
           <a:lstStyle/>
           <a:p>
             <a:pPr algn="ctr">
-              <a:defRPr sz="1100" b="1">
+              <a:defRPr sz="1000" b="1">
                 <a:solidFill>
                   <a:srgbClr val="1E3A8A"/>
                 </a:solidFill>
@@ -7416,8 +8508,8 @@
         </p:nvSpPr>
         <p:spPr>
           <a:xfrm>
-            <a:off x="457200" y="1005840"/>
-            <a:ext cx="5486400" cy="2560320"/>
+            <a:off x="457200" y="914400"/>
+            <a:ext cx="5486400" cy="2651760"/>
           </a:xfrm>
           <a:prstGeom prst="rect">
             <a:avLst/>
@@ -7451,9 +8543,9 @@
           <a:p>
             <a:pPr algn="ctr">
               <a:spcAft>
-                <a:spcPts val="400"/>
+                <a:spcPts val="300"/>
               </a:spcAft>
-              <a:defRPr b="1" sz="1000">
+              <a:defRPr b="1" sz="950">
                 <a:solidFill>
                   <a:srgbClr val="1E3A8A"/>
                 </a:solidFill>
@@ -7466,9 +8558,9 @@
           <a:p>
             <a:pPr>
               <a:spcAft>
-                <a:spcPts val="300"/>
+                <a:spcPts val="200"/>
               </a:spcAft>
-              <a:defRPr sz="850">
+              <a:defRPr sz="800">
                 <a:solidFill>
                   <a:srgbClr val="1E293B"/>
                 </a:solidFill>
@@ -7481,9 +8573,9 @@
           <a:p>
             <a:pPr>
               <a:spcAft>
-                <a:spcPts val="300"/>
+                <a:spcPts val="200"/>
               </a:spcAft>
-              <a:defRPr sz="850">
+              <a:defRPr sz="800">
                 <a:solidFill>
                   <a:srgbClr val="1E293B"/>
                 </a:solidFill>
@@ -7496,9 +8588,9 @@
           <a:p>
             <a:pPr>
               <a:spcAft>
-                <a:spcPts val="300"/>
+                <a:spcPts val="200"/>
               </a:spcAft>
-              <a:defRPr sz="850">
+              <a:defRPr sz="800">
                 <a:solidFill>
                   <a:srgbClr val="1E293B"/>
                 </a:solidFill>
@@ -7518,8 +8610,8 @@
         </p:nvSpPr>
         <p:spPr>
           <a:xfrm>
-            <a:off x="6217920" y="1005840"/>
-            <a:ext cx="5486400" cy="2560320"/>
+            <a:off x="6217920" y="914400"/>
+            <a:ext cx="5486400" cy="2651760"/>
           </a:xfrm>
           <a:prstGeom prst="rect">
             <a:avLst/>
@@ -7553,9 +8645,9 @@
           <a:p>
             <a:pPr algn="ctr">
               <a:spcAft>
-                <a:spcPts val="400"/>
+                <a:spcPts val="300"/>
               </a:spcAft>
-              <a:defRPr b="1" sz="1000">
+              <a:defRPr b="1" sz="950">
                 <a:solidFill>
                   <a:srgbClr val="1E3A8A"/>
                 </a:solidFill>
@@ -7568,9 +8660,9 @@
           <a:p>
             <a:pPr>
               <a:spcAft>
-                <a:spcPts val="300"/>
+                <a:spcPts val="200"/>
               </a:spcAft>
-              <a:defRPr sz="850">
+              <a:defRPr sz="800">
                 <a:solidFill>
                   <a:srgbClr val="1E293B"/>
                 </a:solidFill>
@@ -7583,9 +8675,9 @@
           <a:p>
             <a:pPr>
               <a:spcAft>
-                <a:spcPts val="300"/>
+                <a:spcPts val="200"/>
               </a:spcAft>
-              <a:defRPr sz="850">
+              <a:defRPr sz="800">
                 <a:solidFill>
                   <a:srgbClr val="1E293B"/>
                 </a:solidFill>
@@ -7598,16 +8690,16 @@
           <a:p>
             <a:pPr>
               <a:spcAft>
-                <a:spcPts val="300"/>
+                <a:spcPts val="200"/>
               </a:spcAft>
-              <a:defRPr sz="850">
+              <a:defRPr sz="800">
                 <a:solidFill>
                   <a:srgbClr val="1E293B"/>
                 </a:solidFill>
               </a:defRPr>
             </a:pPr>
             <a:r>
-              <a:t>3. Unit Sale Price (USP) Guidelines &amp; Dual MRP Enforcement Directives (Section 18 &amp; 36).</a:t>
+              <a:t>3. Unit Sale Price (USP) Guidelines &amp; Dual MRP Directives (Section 18 &amp; 36).</a:t>
             </a:r>
           </a:p>
         </p:txBody>
@@ -7620,8 +8712,8 @@
         </p:nvSpPr>
         <p:spPr>
           <a:xfrm>
-            <a:off x="457200" y="3840480"/>
-            <a:ext cx="5486400" cy="2560320"/>
+            <a:off x="457200" y="3749039"/>
+            <a:ext cx="5486400" cy="2651760"/>
           </a:xfrm>
           <a:prstGeom prst="rect">
             <a:avLst/>
@@ -7655,9 +8747,9 @@
           <a:p>
             <a:pPr algn="ctr">
               <a:spcAft>
-                <a:spcPts val="400"/>
+                <a:spcPts val="300"/>
               </a:spcAft>
-              <a:defRPr b="1" sz="1000">
+              <a:defRPr b="1" sz="950">
                 <a:solidFill>
                   <a:srgbClr val="1E3A8A"/>
                 </a:solidFill>
@@ -7670,9 +8762,9 @@
           <a:p>
             <a:pPr>
               <a:spcAft>
-                <a:spcPts val="300"/>
+                <a:spcPts val="200"/>
               </a:spcAft>
-              <a:defRPr sz="850">
+              <a:defRPr sz="800">
                 <a:solidFill>
                   <a:srgbClr val="1E293B"/>
                 </a:solidFill>
@@ -7685,9 +8777,9 @@
           <a:p>
             <a:pPr>
               <a:spcAft>
-                <a:spcPts val="300"/>
+                <a:spcPts val="200"/>
               </a:spcAft>
-              <a:defRPr sz="850">
+              <a:defRPr sz="800">
                 <a:solidFill>
                   <a:srgbClr val="1E293B"/>
                 </a:solidFill>
@@ -7700,9 +8792,9 @@
           <a:p>
             <a:pPr>
               <a:spcAft>
-                <a:spcPts val="300"/>
+                <a:spcPts val="200"/>
               </a:spcAft>
-              <a:defRPr sz="850">
+              <a:defRPr sz="800">
                 <a:solidFill>
                   <a:srgbClr val="1E293B"/>
                 </a:solidFill>
@@ -7715,9 +8807,9 @@
           <a:p>
             <a:pPr>
               <a:spcAft>
-                <a:spcPts val="300"/>
+                <a:spcPts val="200"/>
               </a:spcAft>
-              <a:defRPr sz="850">
+              <a:defRPr sz="800">
                 <a:solidFill>
                   <a:srgbClr val="1E293B"/>
                 </a:solidFill>
@@ -7737,8 +8829,8 @@
         </p:nvSpPr>
         <p:spPr>
           <a:xfrm>
-            <a:off x="6217920" y="3840480"/>
-            <a:ext cx="5486400" cy="2560320"/>
+            <a:off x="6217920" y="3749039"/>
+            <a:ext cx="5486400" cy="2651760"/>
           </a:xfrm>
           <a:prstGeom prst="rect">
             <a:avLst/>
@@ -7772,9 +8864,9 @@
           <a:p>
             <a:pPr algn="ctr">
               <a:spcAft>
-                <a:spcPts val="400"/>
+                <a:spcPts val="300"/>
               </a:spcAft>
-              <a:defRPr b="1" sz="1000">
+              <a:defRPr b="1" sz="950">
                 <a:solidFill>
                   <a:srgbClr val="1E3A8A"/>
                 </a:solidFill>
@@ -7786,62 +8878,1184 @@
           </a:p>
           <a:p>
             <a:pPr>
+              <a:spcAft>
+                <a:spcPts val="200"/>
+              </a:spcAft>
+              <a:defRPr sz="800">
+                <a:solidFill>
+                  <a:srgbClr val="1E293B"/>
+                </a:solidFill>
+              </a:defRPr>
+            </a:pPr>
+            <a:r>
+              <a:t>1. INGRAM (National Consumer Helpline NCH 1915 / consumerhelpline.gov.in).</a:t>
+            </a:r>
+          </a:p>
+          <a:p>
+            <a:pPr>
+              <a:spcAft>
+                <a:spcPts val="200"/>
+              </a:spcAft>
+              <a:defRPr sz="800">
+                <a:solidFill>
+                  <a:srgbClr val="1E293B"/>
+                </a:solidFill>
+              </a:defRPr>
+            </a:pPr>
+            <a:r>
+              <a:t>2. FSSAI License &amp; Food Safety Standards Act (Section 31 Verification Registry).</a:t>
+            </a:r>
+          </a:p>
+          <a:p>
+            <a:pPr>
+              <a:spcAft>
+                <a:spcPts val="200"/>
+              </a:spcAft>
+              <a:defRPr sz="800">
+                <a:solidFill>
+                  <a:srgbClr val="1E293B"/>
+                </a:solidFill>
+              </a:defRPr>
+            </a:pPr>
+            <a:r>
+              <a:t>3. Bureau of Indian Standards (BIS) IS 10001 Standard Packaged Quantities.</a:t>
+            </a:r>
+          </a:p>
+          <a:p>
+            <a:pPr>
+              <a:spcAft>
+                <a:spcPts val="200"/>
+              </a:spcAft>
+              <a:defRPr sz="800">
+                <a:solidFill>
+                  <a:srgbClr val="1E293B"/>
+                </a:solidFill>
+              </a:defRPr>
+            </a:pPr>
+            <a:r>
+              <a:t>4. e-Daakhil Consumer Court Grievance Filing Integration.</a:t>
+            </a:r>
+          </a:p>
+        </p:txBody>
+      </p:sp>
+    </p:spTree>
+  </p:cSld>
+  <p:clrMapOvr>
+    <a:masterClrMapping/>
+  </p:clrMapOvr>
+</p:sld>
+</file>
+
+<file path=ppt/slides/slide7.xml><?xml version="1.0" encoding="utf-8"?>
+<p:sld xmlns:a="http://schemas.openxmlformats.org/drawingml/2006/main" xmlns:p="http://schemas.openxmlformats.org/presentationml/2006/main" xmlns:r="http://schemas.openxmlformats.org/officeDocument/2006/relationships">
+  <p:cSld>
+    <p:spTree>
+      <p:nvGrpSpPr>
+        <p:cNvPr id="1" name=""/>
+        <p:cNvGrpSpPr/>
+        <p:nvPr/>
+      </p:nvGrpSpPr>
+      <p:grpSpPr/>
+      <p:sp>
+        <p:nvSpPr>
+          <p:cNvPr id="2" name="Oval 1"/>
+          <p:cNvSpPr/>
+          <p:nvPr/>
+        </p:nvSpPr>
+        <p:spPr>
+          <a:xfrm>
+            <a:off x="365760" y="228600"/>
+            <a:ext cx="1371600" cy="502920"/>
+          </a:xfrm>
+          <a:prstGeom prst="ellipse">
+            <a:avLst/>
+          </a:prstGeom>
+          <a:solidFill>
+            <a:srgbClr val="FFFFFF"/>
+          </a:solidFill>
+          <a:ln w="19050">
+            <a:solidFill>
+              <a:srgbClr val="1E3A8A"/>
+            </a:solidFill>
+          </a:ln>
+        </p:spPr>
+        <p:style>
+          <a:lnRef idx="1">
+            <a:schemeClr val="accent1"/>
+          </a:lnRef>
+          <a:fillRef idx="3">
+            <a:schemeClr val="accent1"/>
+          </a:fillRef>
+          <a:effectRef idx="2">
+            <a:schemeClr val="accent1"/>
+          </a:effectRef>
+          <a:fontRef idx="minor">
+            <a:schemeClr val="lt1"/>
+          </a:fontRef>
+        </p:style>
+        <p:txBody>
+          <a:bodyPr rtlCol="0" anchor="ctr"/>
+          <a:lstStyle/>
+          <a:p>
+            <a:pPr algn="ctr">
+              <a:defRPr sz="1100" b="1">
+                <a:solidFill>
+                  <a:srgbClr val="1E3A8A"/>
+                </a:solidFill>
+                <a:latin typeface="Arial"/>
+              </a:defRPr>
+            </a:pPr>
+            <a:r>
+              <a:t>LegalMetriX</a:t>
+            </a:r>
+          </a:p>
+        </p:txBody>
+      </p:sp>
+      <p:sp>
+        <p:nvSpPr>
+          <p:cNvPr id="3" name="TextBox 2"/>
+          <p:cNvSpPr txBox="1"/>
+          <p:nvPr/>
+        </p:nvSpPr>
+        <p:spPr>
+          <a:xfrm>
+            <a:off x="1920240" y="137160"/>
+            <a:ext cx="7772400" cy="685800"/>
+          </a:xfrm>
+          <a:prstGeom prst="rect">
+            <a:avLst/>
+          </a:prstGeom>
+          <a:noFill/>
+        </p:spPr>
+        <p:txBody>
+          <a:bodyPr wrap="none">
+            <a:spAutoFit/>
+          </a:bodyPr>
+          <a:lstStyle/>
+          <a:p>
+            <a:pPr algn="ctr">
+              <a:defRPr sz="1900" b="1">
+                <a:solidFill>
+                  <a:srgbClr val="1E3A8A"/>
+                </a:solidFill>
+                <a:latin typeface="Arial"/>
+              </a:defRPr>
+            </a:pPr>
+            <a:r>
+              <a:t>JUDGES Q&amp;A DEFENSE: AI &amp; COMPUTER VISION</a:t>
+            </a:r>
+          </a:p>
+        </p:txBody>
+      </p:sp>
+      <p:sp>
+        <p:nvSpPr>
+          <p:cNvPr id="4" name="TextBox 3"/>
+          <p:cNvSpPr txBox="1"/>
+          <p:nvPr/>
+        </p:nvSpPr>
+        <p:spPr>
+          <a:xfrm>
+            <a:off x="9875520" y="137160"/>
+            <a:ext cx="2011680" cy="685800"/>
+          </a:xfrm>
+          <a:prstGeom prst="rect">
+            <a:avLst/>
+          </a:prstGeom>
+          <a:noFill/>
+        </p:spPr>
+        <p:txBody>
+          <a:bodyPr wrap="none">
+            <a:spAutoFit/>
+          </a:bodyPr>
+          <a:lstStyle/>
+          <a:p>
+            <a:pPr algn="ctr">
+              <a:defRPr sz="1000" b="1">
+                <a:solidFill>
+                  <a:srgbClr val="991B1B"/>
+                </a:solidFill>
+                <a:latin typeface="Arial"/>
+              </a:defRPr>
+            </a:pPr>
+            <a:r>
+              <a:t>JUDGES Q&amp;A</a:t>
+            </a:r>
+            <a:br/>
+            <a:r>
+              <a:t>DEFENSE GUIDE</a:t>
+            </a:r>
+          </a:p>
+        </p:txBody>
+      </p:sp>
+      <p:sp>
+        <p:nvSpPr>
+          <p:cNvPr id="5" name="Rounded Rectangle 4"/>
+          <p:cNvSpPr/>
+          <p:nvPr/>
+        </p:nvSpPr>
+        <p:spPr>
+          <a:xfrm>
+            <a:off x="457200" y="1005840"/>
+            <a:ext cx="11277295" cy="1691640"/>
+          </a:xfrm>
+          <a:prstGeom prst="roundRect">
+            <a:avLst/>
+          </a:prstGeom>
+          <a:solidFill>
+            <a:srgbClr val="EFF6FF"/>
+          </a:solidFill>
+          <a:ln w="12700">
+            <a:solidFill>
+              <a:srgbClr val="2563EB"/>
+            </a:solidFill>
+          </a:ln>
+        </p:spPr>
+        <p:style>
+          <a:lnRef idx="1">
+            <a:schemeClr val="accent1"/>
+          </a:lnRef>
+          <a:fillRef idx="3">
+            <a:schemeClr val="accent1"/>
+          </a:fillRef>
+          <a:effectRef idx="2">
+            <a:schemeClr val="accent1"/>
+          </a:effectRef>
+          <a:fontRef idx="minor">
+            <a:schemeClr val="lt1"/>
+          </a:fontRef>
+        </p:style>
+        <p:txBody>
+          <a:bodyPr rtlCol="0" anchor="ctr" wrap="square"/>
+          <a:lstStyle/>
+          <a:p>
+            <a:pPr algn="ctr">
               <a:spcAft>
                 <a:spcPts val="300"/>
               </a:spcAft>
-              <a:defRPr sz="850">
+              <a:defRPr b="1" sz="1100">
+                <a:solidFill>
+                  <a:srgbClr val="1E3A8A"/>
+                </a:solidFill>
+              </a:defRPr>
+            </a:pPr>
+            <a:r>
+              <a:t>Q1: Why use dual-pass PaddleOCR + Gemini Vision instead of Gemini alone?</a:t>
+            </a:r>
+          </a:p>
+          <a:p>
+            <a:r>
+              <a:rPr b="1" sz="950">
+                <a:solidFill>
+                  <a:srgbClr val="166534"/>
+                </a:solidFill>
+              </a:rPr>
+              <a:t>Winning Answer: </a:t>
+            </a:r>
+            <a:r>
+              <a:rPr sz="900">
                 <a:solidFill>
                   <a:srgbClr val="1E293B"/>
                 </a:solidFill>
-              </a:defRPr>
-            </a:pPr>
-            <a:r>
-              <a:t>1. INGRAM (National Consumer Helpline NCH 1915 / consumerhelpline.gov.in).</a:t>
-            </a:r>
-          </a:p>
-          <a:p>
-            <a:pPr>
+              </a:rPr>
+              <a:t>Using a dual-pass pipeline solves cost, latency, and hallucination. PaddleOCR performs local, zero-cost character bounding box detection without hallucination. Gemini Vision acts as a semantic context layer (verifying 'Incl. of all taxes' or distinguishing manufacturer vs packer). If PaddleOCR detects zero text, Gemini is strictly prevented from guessing.</a:t>
+            </a:r>
+          </a:p>
+        </p:txBody>
+      </p:sp>
+      <p:sp>
+        <p:nvSpPr>
+          <p:cNvPr id="6" name="Rounded Rectangle 5"/>
+          <p:cNvSpPr/>
+          <p:nvPr/>
+        </p:nvSpPr>
+        <p:spPr>
+          <a:xfrm>
+            <a:off x="457200" y="2834640"/>
+            <a:ext cx="11277295" cy="1691640"/>
+          </a:xfrm>
+          <a:prstGeom prst="roundRect">
+            <a:avLst/>
+          </a:prstGeom>
+          <a:solidFill>
+            <a:srgbClr val="F8FAFC"/>
+          </a:solidFill>
+          <a:ln w="12700">
+            <a:solidFill>
+              <a:srgbClr val="CBD5E1"/>
+            </a:solidFill>
+          </a:ln>
+        </p:spPr>
+        <p:style>
+          <a:lnRef idx="1">
+            <a:schemeClr val="accent1"/>
+          </a:lnRef>
+          <a:fillRef idx="3">
+            <a:schemeClr val="accent1"/>
+          </a:fillRef>
+          <a:effectRef idx="2">
+            <a:schemeClr val="accent1"/>
+          </a:effectRef>
+          <a:fontRef idx="minor">
+            <a:schemeClr val="lt1"/>
+          </a:fontRef>
+        </p:style>
+        <p:txBody>
+          <a:bodyPr rtlCol="0" anchor="ctr" wrap="square"/>
+          <a:lstStyle/>
+          <a:p>
+            <a:pPr algn="ctr">
               <a:spcAft>
                 <a:spcPts val="300"/>
               </a:spcAft>
-              <a:defRPr sz="850">
+              <a:defRPr b="1" sz="1100">
+                <a:solidFill>
+                  <a:srgbClr val="1E3A8A"/>
+                </a:solidFill>
+              </a:defRPr>
+            </a:pPr>
+            <a:r>
+              <a:t>Q2: How do you handle motion blur in 360° rotational video scanning?</a:t>
+            </a:r>
+          </a:p>
+          <a:p>
+            <a:r>
+              <a:rPr b="1" sz="950">
+                <a:solidFill>
+                  <a:srgbClr val="166534"/>
+                </a:solidFill>
+              </a:rPr>
+              <a:t>Winning Answer: </a:t>
+            </a:r>
+            <a:r>
+              <a:rPr sz="900">
                 <a:solidFill>
                   <a:srgbClr val="1E293B"/>
                 </a:solidFill>
-              </a:defRPr>
-            </a:pPr>
-            <a:r>
-              <a:t>2. FSSAI License &amp; Food Safety Standards Act (Section 31 Verification Registry).</a:t>
-            </a:r>
-          </a:p>
-          <a:p>
-            <a:pPr>
+              </a:rPr>
+              <a:t>We sample 24–36 frames across the rotation arc and compute the 2D Laplacian variance: Sharpness = Var(Laplacian(I)). Blurry frames caused by quick rotation fall below our dynamic threshold and are automatically discarded. Only the sharpest frame from each 90° quadrant is analyzed.</a:t>
+            </a:r>
+          </a:p>
+        </p:txBody>
+      </p:sp>
+      <p:sp>
+        <p:nvSpPr>
+          <p:cNvPr id="7" name="Rounded Rectangle 6"/>
+          <p:cNvSpPr/>
+          <p:nvPr/>
+        </p:nvSpPr>
+        <p:spPr>
+          <a:xfrm>
+            <a:off x="457200" y="4663440"/>
+            <a:ext cx="11277295" cy="1691640"/>
+          </a:xfrm>
+          <a:prstGeom prst="roundRect">
+            <a:avLst/>
+          </a:prstGeom>
+          <a:solidFill>
+            <a:srgbClr val="EFF6FF"/>
+          </a:solidFill>
+          <a:ln w="12700">
+            <a:solidFill>
+              <a:srgbClr val="2563EB"/>
+            </a:solidFill>
+          </a:ln>
+        </p:spPr>
+        <p:style>
+          <a:lnRef idx="1">
+            <a:schemeClr val="accent1"/>
+          </a:lnRef>
+          <a:fillRef idx="3">
+            <a:schemeClr val="accent1"/>
+          </a:fillRef>
+          <a:effectRef idx="2">
+            <a:schemeClr val="accent1"/>
+          </a:effectRef>
+          <a:fontRef idx="minor">
+            <a:schemeClr val="lt1"/>
+          </a:fontRef>
+        </p:style>
+        <p:txBody>
+          <a:bodyPr rtlCol="0" anchor="ctr" wrap="square"/>
+          <a:lstStyle/>
+          <a:p>
+            <a:pPr algn="ctr">
               <a:spcAft>
                 <a:spcPts val="300"/>
               </a:spcAft>
-              <a:defRPr sz="850">
+              <a:defRPr b="1" sz="1100">
+                <a:solidFill>
+                  <a:srgbClr val="1E3A8A"/>
+                </a:solidFill>
+              </a:defRPr>
+            </a:pPr>
+            <a:r>
+              <a:t>Q3: How do you handle glare on shiny plastic and metallic wrappers?</a:t>
+            </a:r>
+          </a:p>
+          <a:p>
+            <a:r>
+              <a:rPr b="1" sz="950">
+                <a:solidFill>
+                  <a:srgbClr val="166534"/>
+                </a:solidFill>
+              </a:rPr>
+              <a:t>Winning Answer: </a:t>
+            </a:r>
+            <a:r>
+              <a:rPr sz="900">
                 <a:solidFill>
                   <a:srgbClr val="1E293B"/>
                 </a:solidFill>
-              </a:defRPr>
-            </a:pPr>
-            <a:r>
-              <a:t>3. Bureau of Indian Standards (BIS) IS 10001 Standard Packaged Quantities.</a:t>
-            </a:r>
-          </a:p>
-          <a:p>
-            <a:pPr>
+              </a:rPr>
+              <a:t>3-tier defense: (1) Client-side quality gate checking reflection; (2) Adaptive Histogram Equalization (CLAHE) balancing dynamic range; (3) Anti-hallucination guardrail: if text is obscured by glare, outputs 'NEEDS VERIFICATION — Glare Obscuration' rather than falsely failing the product.</a:t>
+            </a:r>
+          </a:p>
+        </p:txBody>
+      </p:sp>
+    </p:spTree>
+  </p:cSld>
+  <p:clrMapOvr>
+    <a:masterClrMapping/>
+  </p:clrMapOvr>
+</p:sld>
+</file>
+
+<file path=ppt/slides/slide8.xml><?xml version="1.0" encoding="utf-8"?>
+<p:sld xmlns:a="http://schemas.openxmlformats.org/drawingml/2006/main" xmlns:p="http://schemas.openxmlformats.org/presentationml/2006/main" xmlns:r="http://schemas.openxmlformats.org/officeDocument/2006/relationships">
+  <p:cSld>
+    <p:spTree>
+      <p:nvGrpSpPr>
+        <p:cNvPr id="1" name=""/>
+        <p:cNvGrpSpPr/>
+        <p:nvPr/>
+      </p:nvGrpSpPr>
+      <p:grpSpPr/>
+      <p:sp>
+        <p:nvSpPr>
+          <p:cNvPr id="2" name="Oval 1"/>
+          <p:cNvSpPr/>
+          <p:nvPr/>
+        </p:nvSpPr>
+        <p:spPr>
+          <a:xfrm>
+            <a:off x="365760" y="228600"/>
+            <a:ext cx="1371600" cy="502920"/>
+          </a:xfrm>
+          <a:prstGeom prst="ellipse">
+            <a:avLst/>
+          </a:prstGeom>
+          <a:solidFill>
+            <a:srgbClr val="FFFFFF"/>
+          </a:solidFill>
+          <a:ln w="19050">
+            <a:solidFill>
+              <a:srgbClr val="1E3A8A"/>
+            </a:solidFill>
+          </a:ln>
+        </p:spPr>
+        <p:style>
+          <a:lnRef idx="1">
+            <a:schemeClr val="accent1"/>
+          </a:lnRef>
+          <a:fillRef idx="3">
+            <a:schemeClr val="accent1"/>
+          </a:fillRef>
+          <a:effectRef idx="2">
+            <a:schemeClr val="accent1"/>
+          </a:effectRef>
+          <a:fontRef idx="minor">
+            <a:schemeClr val="lt1"/>
+          </a:fontRef>
+        </p:style>
+        <p:txBody>
+          <a:bodyPr rtlCol="0" anchor="ctr"/>
+          <a:lstStyle/>
+          <a:p>
+            <a:pPr algn="ctr">
+              <a:defRPr sz="1100" b="1">
+                <a:solidFill>
+                  <a:srgbClr val="1E3A8A"/>
+                </a:solidFill>
+                <a:latin typeface="Arial"/>
+              </a:defRPr>
+            </a:pPr>
+            <a:r>
+              <a:t>LegalMetriX</a:t>
+            </a:r>
+          </a:p>
+        </p:txBody>
+      </p:sp>
+      <p:sp>
+        <p:nvSpPr>
+          <p:cNvPr id="3" name="TextBox 2"/>
+          <p:cNvSpPr txBox="1"/>
+          <p:nvPr/>
+        </p:nvSpPr>
+        <p:spPr>
+          <a:xfrm>
+            <a:off x="1920240" y="137160"/>
+            <a:ext cx="7772400" cy="685800"/>
+          </a:xfrm>
+          <a:prstGeom prst="rect">
+            <a:avLst/>
+          </a:prstGeom>
+          <a:noFill/>
+        </p:spPr>
+        <p:txBody>
+          <a:bodyPr wrap="none">
+            <a:spAutoFit/>
+          </a:bodyPr>
+          <a:lstStyle/>
+          <a:p>
+            <a:pPr algn="ctr">
+              <a:defRPr sz="1900" b="1">
+                <a:solidFill>
+                  <a:srgbClr val="1E3A8A"/>
+                </a:solidFill>
+                <a:latin typeface="Arial"/>
+              </a:defRPr>
+            </a:pPr>
+            <a:r>
+              <a:t>JUDGES Q&amp;A DEFENSE: LEGAL METROLOGY ACT &amp; RULES</a:t>
+            </a:r>
+          </a:p>
+        </p:txBody>
+      </p:sp>
+      <p:sp>
+        <p:nvSpPr>
+          <p:cNvPr id="4" name="TextBox 3"/>
+          <p:cNvSpPr txBox="1"/>
+          <p:nvPr/>
+        </p:nvSpPr>
+        <p:spPr>
+          <a:xfrm>
+            <a:off x="9875520" y="137160"/>
+            <a:ext cx="2011680" cy="685800"/>
+          </a:xfrm>
+          <a:prstGeom prst="rect">
+            <a:avLst/>
+          </a:prstGeom>
+          <a:noFill/>
+        </p:spPr>
+        <p:txBody>
+          <a:bodyPr wrap="none">
+            <a:spAutoFit/>
+          </a:bodyPr>
+          <a:lstStyle/>
+          <a:p>
+            <a:pPr algn="ctr">
+              <a:defRPr sz="1000" b="1">
+                <a:solidFill>
+                  <a:srgbClr val="991B1B"/>
+                </a:solidFill>
+                <a:latin typeface="Arial"/>
+              </a:defRPr>
+            </a:pPr>
+            <a:r>
+              <a:t>JUDGES Q&amp;A</a:t>
+            </a:r>
+            <a:br/>
+            <a:r>
+              <a:t>DEFENSE GUIDE</a:t>
+            </a:r>
+          </a:p>
+        </p:txBody>
+      </p:sp>
+      <p:sp>
+        <p:nvSpPr>
+          <p:cNvPr id="5" name="Rounded Rectangle 4"/>
+          <p:cNvSpPr/>
+          <p:nvPr/>
+        </p:nvSpPr>
+        <p:spPr>
+          <a:xfrm>
+            <a:off x="457200" y="1005840"/>
+            <a:ext cx="11277295" cy="1691640"/>
+          </a:xfrm>
+          <a:prstGeom prst="roundRect">
+            <a:avLst/>
+          </a:prstGeom>
+          <a:solidFill>
+            <a:srgbClr val="EFF6FF"/>
+          </a:solidFill>
+          <a:ln w="12700">
+            <a:solidFill>
+              <a:srgbClr val="2563EB"/>
+            </a:solidFill>
+          </a:ln>
+        </p:spPr>
+        <p:style>
+          <a:lnRef idx="1">
+            <a:schemeClr val="accent1"/>
+          </a:lnRef>
+          <a:fillRef idx="3">
+            <a:schemeClr val="accent1"/>
+          </a:fillRef>
+          <a:effectRef idx="2">
+            <a:schemeClr val="accent1"/>
+          </a:effectRef>
+          <a:fontRef idx="minor">
+            <a:schemeClr val="lt1"/>
+          </a:fontRef>
+        </p:style>
+        <p:txBody>
+          <a:bodyPr rtlCol="0" anchor="ctr" wrap="square"/>
+          <a:lstStyle/>
+          <a:p>
+            <a:pPr algn="ctr">
               <a:spcAft>
                 <a:spcPts val="300"/>
               </a:spcAft>
-              <a:defRPr sz="850">
+              <a:defRPr b="1" sz="1100">
+                <a:solidFill>
+                  <a:srgbClr val="1E3A8A"/>
+                </a:solidFill>
+              </a:defRPr>
+            </a:pPr>
+            <a:r>
+              <a:t>Q4: Can AI legally issue a fine or penalize a manufacturer in court?</a:t>
+            </a:r>
+          </a:p>
+          <a:p>
+            <a:r>
+              <a:rPr b="1" sz="950">
+                <a:solidFill>
+                  <a:srgbClr val="166534"/>
+                </a:solidFill>
+              </a:rPr>
+              <a:t>Winning Answer: </a:t>
+            </a:r>
+            <a:r>
+              <a:rPr sz="900">
                 <a:solidFill>
                   <a:srgbClr val="1E293B"/>
                 </a:solidFill>
-              </a:defRPr>
-            </a:pPr>
-            <a:r>
-              <a:t>4. e-Daakhil Consumer Court Grievance Filing Integration.</a:t>
+              </a:rPr>
+              <a:t>Absolutely not. Under the Legal Metrology Act 2009, only authorized gazetted officers (Inspectors or Deputy Controllers) possess statutory authority to issue notices or compound offenses. Our AI is strictly assistive. A case only becomes legally enforceable when an officer reviews the evidence, selects a verdict, and applies their Digital Signature Seal.</a:t>
+            </a:r>
+          </a:p>
+        </p:txBody>
+      </p:sp>
+      <p:sp>
+        <p:nvSpPr>
+          <p:cNvPr id="6" name="Rounded Rectangle 5"/>
+          <p:cNvSpPr/>
+          <p:nvPr/>
+        </p:nvSpPr>
+        <p:spPr>
+          <a:xfrm>
+            <a:off x="457200" y="2834640"/>
+            <a:ext cx="11277295" cy="1691640"/>
+          </a:xfrm>
+          <a:prstGeom prst="roundRect">
+            <a:avLst/>
+          </a:prstGeom>
+          <a:solidFill>
+            <a:srgbClr val="F8FAFC"/>
+          </a:solidFill>
+          <a:ln w="12700">
+            <a:solidFill>
+              <a:srgbClr val="CBD5E1"/>
+            </a:solidFill>
+          </a:ln>
+        </p:spPr>
+        <p:style>
+          <a:lnRef idx="1">
+            <a:schemeClr val="accent1"/>
+          </a:lnRef>
+          <a:fillRef idx="3">
+            <a:schemeClr val="accent1"/>
+          </a:fillRef>
+          <a:effectRef idx="2">
+            <a:schemeClr val="accent1"/>
+          </a:effectRef>
+          <a:fontRef idx="minor">
+            <a:schemeClr val="lt1"/>
+          </a:fontRef>
+        </p:style>
+        <p:txBody>
+          <a:bodyPr rtlCol="0" anchor="ctr" wrap="square"/>
+          <a:lstStyle/>
+          <a:p>
+            <a:pPr algn="ctr">
+              <a:spcAft>
+                <a:spcPts val="300"/>
+              </a:spcAft>
+              <a:defRPr b="1" sz="1100">
+                <a:solidFill>
+                  <a:srgbClr val="1E3A8A"/>
+                </a:solidFill>
+              </a:defRPr>
+            </a:pPr>
+            <a:r>
+              <a:t>Q5: What specific rules of PCR 2011 do you evaluate?</a:t>
+            </a:r>
+          </a:p>
+          <a:p>
+            <a:r>
+              <a:rPr b="1" sz="950">
+                <a:solidFill>
+                  <a:srgbClr val="166534"/>
+                </a:solidFill>
+              </a:rPr>
+              <a:t>Winning Answer: </a:t>
+            </a:r>
+            <a:r>
+              <a:rPr sz="900">
+                <a:solidFill>
+                  <a:srgbClr val="1E293B"/>
+                </a:solidFill>
+              </a:rPr>
+              <a:t>All mandatory declarations under Rule 6(1) and Rule 12: Rule 6(1)(a) Generic Name, 6(1)(b) Net Qty in metric units (g, kg, ml, L), 6(1)(c) Mfg/Packing Date, 6(1)(d) Expiry Date, 6(1)(e) MRP 'Rs. XX (Incl. of all taxes)', 6(1)(f) Complete Address with PIN code, 6(1)(g) Consumer Care details, and 6(1)(n) Country of Origin.</a:t>
+            </a:r>
+          </a:p>
+        </p:txBody>
+      </p:sp>
+      <p:sp>
+        <p:nvSpPr>
+          <p:cNvPr id="7" name="Rounded Rectangle 6"/>
+          <p:cNvSpPr/>
+          <p:nvPr/>
+        </p:nvSpPr>
+        <p:spPr>
+          <a:xfrm>
+            <a:off x="457200" y="4663440"/>
+            <a:ext cx="11277295" cy="1691640"/>
+          </a:xfrm>
+          <a:prstGeom prst="roundRect">
+            <a:avLst/>
+          </a:prstGeom>
+          <a:solidFill>
+            <a:srgbClr val="EFF6FF"/>
+          </a:solidFill>
+          <a:ln w="12700">
+            <a:solidFill>
+              <a:srgbClr val="2563EB"/>
+            </a:solidFill>
+          </a:ln>
+        </p:spPr>
+        <p:style>
+          <a:lnRef idx="1">
+            <a:schemeClr val="accent1"/>
+          </a:lnRef>
+          <a:fillRef idx="3">
+            <a:schemeClr val="accent1"/>
+          </a:fillRef>
+          <a:effectRef idx="2">
+            <a:schemeClr val="accent1"/>
+          </a:effectRef>
+          <a:fontRef idx="minor">
+            <a:schemeClr val="lt1"/>
+          </a:fontRef>
+        </p:style>
+        <p:txBody>
+          <a:bodyPr rtlCol="0" anchor="ctr" wrap="square"/>
+          <a:lstStyle/>
+          <a:p>
+            <a:pPr algn="ctr">
+              <a:spcAft>
+                <a:spcPts val="300"/>
+              </a:spcAft>
+              <a:defRPr b="1" sz="1100">
+                <a:solidFill>
+                  <a:srgbClr val="1E3A8A"/>
+                </a:solidFill>
+              </a:defRPr>
+            </a:pPr>
+            <a:r>
+              <a:t>Q6: How do you detect Dual MRP stickers pasted over packaging?</a:t>
+            </a:r>
+          </a:p>
+          <a:p>
+            <a:r>
+              <a:rPr b="1" sz="950">
+                <a:solidFill>
+                  <a:srgbClr val="166534"/>
+                </a:solidFill>
+              </a:rPr>
+              <a:t>Winning Answer: </a:t>
+            </a:r>
+            <a:r>
+              <a:rPr sz="900">
+                <a:solidFill>
+                  <a:srgbClr val="1E293B"/>
+                </a:solidFill>
+              </a:rPr>
+              <a:t>Dual MRP violates Section 18. Our engine checks for multiple distinct prices matching 'Rs.' / 'MRP' on the same panel, as well as detecting bounding-box overlays indicating a price sticker pasted over pre-printed text. It immediately flags a High-Priority Potential Violation.</a:t>
+            </a:r>
+          </a:p>
+        </p:txBody>
+      </p:sp>
+    </p:spTree>
+  </p:cSld>
+  <p:clrMapOvr>
+    <a:masterClrMapping/>
+  </p:clrMapOvr>
+</p:sld>
+</file>
+
+<file path=ppt/slides/slide9.xml><?xml version="1.0" encoding="utf-8"?>
+<p:sld xmlns:a="http://schemas.openxmlformats.org/drawingml/2006/main" xmlns:p="http://schemas.openxmlformats.org/presentationml/2006/main" xmlns:r="http://schemas.openxmlformats.org/officeDocument/2006/relationships">
+  <p:cSld>
+    <p:spTree>
+      <p:nvGrpSpPr>
+        <p:cNvPr id="1" name=""/>
+        <p:cNvGrpSpPr/>
+        <p:nvPr/>
+      </p:nvGrpSpPr>
+      <p:grpSpPr/>
+      <p:sp>
+        <p:nvSpPr>
+          <p:cNvPr id="2" name="Oval 1"/>
+          <p:cNvSpPr/>
+          <p:nvPr/>
+        </p:nvSpPr>
+        <p:spPr>
+          <a:xfrm>
+            <a:off x="365760" y="228600"/>
+            <a:ext cx="1371600" cy="502920"/>
+          </a:xfrm>
+          <a:prstGeom prst="ellipse">
+            <a:avLst/>
+          </a:prstGeom>
+          <a:solidFill>
+            <a:srgbClr val="FFFFFF"/>
+          </a:solidFill>
+          <a:ln w="19050">
+            <a:solidFill>
+              <a:srgbClr val="1E3A8A"/>
+            </a:solidFill>
+          </a:ln>
+        </p:spPr>
+        <p:style>
+          <a:lnRef idx="1">
+            <a:schemeClr val="accent1"/>
+          </a:lnRef>
+          <a:fillRef idx="3">
+            <a:schemeClr val="accent1"/>
+          </a:fillRef>
+          <a:effectRef idx="2">
+            <a:schemeClr val="accent1"/>
+          </a:effectRef>
+          <a:fontRef idx="minor">
+            <a:schemeClr val="lt1"/>
+          </a:fontRef>
+        </p:style>
+        <p:txBody>
+          <a:bodyPr rtlCol="0" anchor="ctr"/>
+          <a:lstStyle/>
+          <a:p>
+            <a:pPr algn="ctr">
+              <a:defRPr sz="1100" b="1">
+                <a:solidFill>
+                  <a:srgbClr val="1E3A8A"/>
+                </a:solidFill>
+                <a:latin typeface="Arial"/>
+              </a:defRPr>
+            </a:pPr>
+            <a:r>
+              <a:t>LegalMetriX</a:t>
+            </a:r>
+          </a:p>
+        </p:txBody>
+      </p:sp>
+      <p:sp>
+        <p:nvSpPr>
+          <p:cNvPr id="3" name="TextBox 2"/>
+          <p:cNvSpPr txBox="1"/>
+          <p:nvPr/>
+        </p:nvSpPr>
+        <p:spPr>
+          <a:xfrm>
+            <a:off x="1920240" y="137160"/>
+            <a:ext cx="7772400" cy="685800"/>
+          </a:xfrm>
+          <a:prstGeom prst="rect">
+            <a:avLst/>
+          </a:prstGeom>
+          <a:noFill/>
+        </p:spPr>
+        <p:txBody>
+          <a:bodyPr wrap="none">
+            <a:spAutoFit/>
+          </a:bodyPr>
+          <a:lstStyle/>
+          <a:p>
+            <a:pPr algn="ctr">
+              <a:defRPr sz="1900" b="1">
+                <a:solidFill>
+                  <a:srgbClr val="1E3A8A"/>
+                </a:solidFill>
+                <a:latin typeface="Arial"/>
+              </a:defRPr>
+            </a:pPr>
+            <a:r>
+              <a:t>JUDGES Q&amp;A DEFENSE: SECURITY, INTEGRITY &amp; TAMPER-PROOFING</a:t>
+            </a:r>
+          </a:p>
+        </p:txBody>
+      </p:sp>
+      <p:sp>
+        <p:nvSpPr>
+          <p:cNvPr id="4" name="TextBox 3"/>
+          <p:cNvSpPr txBox="1"/>
+          <p:nvPr/>
+        </p:nvSpPr>
+        <p:spPr>
+          <a:xfrm>
+            <a:off x="9875520" y="137160"/>
+            <a:ext cx="2011680" cy="685800"/>
+          </a:xfrm>
+          <a:prstGeom prst="rect">
+            <a:avLst/>
+          </a:prstGeom>
+          <a:noFill/>
+        </p:spPr>
+        <p:txBody>
+          <a:bodyPr wrap="none">
+            <a:spAutoFit/>
+          </a:bodyPr>
+          <a:lstStyle/>
+          <a:p>
+            <a:pPr algn="ctr">
+              <a:defRPr sz="1000" b="1">
+                <a:solidFill>
+                  <a:srgbClr val="991B1B"/>
+                </a:solidFill>
+                <a:latin typeface="Arial"/>
+              </a:defRPr>
+            </a:pPr>
+            <a:r>
+              <a:t>JUDGES Q&amp;A</a:t>
+            </a:r>
+            <a:br/>
+            <a:r>
+              <a:t>DEFENSE GUIDE</a:t>
+            </a:r>
+          </a:p>
+        </p:txBody>
+      </p:sp>
+      <p:sp>
+        <p:nvSpPr>
+          <p:cNvPr id="5" name="Rounded Rectangle 4"/>
+          <p:cNvSpPr/>
+          <p:nvPr/>
+        </p:nvSpPr>
+        <p:spPr>
+          <a:xfrm>
+            <a:off x="457200" y="1005840"/>
+            <a:ext cx="11277295" cy="1691640"/>
+          </a:xfrm>
+          <a:prstGeom prst="roundRect">
+            <a:avLst/>
+          </a:prstGeom>
+          <a:solidFill>
+            <a:srgbClr val="EFF6FF"/>
+          </a:solidFill>
+          <a:ln w="12700">
+            <a:solidFill>
+              <a:srgbClr val="2563EB"/>
+            </a:solidFill>
+          </a:ln>
+        </p:spPr>
+        <p:style>
+          <a:lnRef idx="1">
+            <a:schemeClr val="accent1"/>
+          </a:lnRef>
+          <a:fillRef idx="3">
+            <a:schemeClr val="accent1"/>
+          </a:fillRef>
+          <a:effectRef idx="2">
+            <a:schemeClr val="accent1"/>
+          </a:effectRef>
+          <a:fontRef idx="minor">
+            <a:schemeClr val="lt1"/>
+          </a:fontRef>
+        </p:style>
+        <p:txBody>
+          <a:bodyPr rtlCol="0" anchor="ctr" wrap="square"/>
+          <a:lstStyle/>
+          <a:p>
+            <a:pPr algn="ctr">
+              <a:spcAft>
+                <a:spcPts val="300"/>
+              </a:spcAft>
+              <a:defRPr b="1" sz="1100">
+                <a:solidFill>
+                  <a:srgbClr val="1E3A8A"/>
+                </a:solidFill>
+              </a:defRPr>
+            </a:pPr>
+            <a:r>
+              <a:t>Q7: How do you ensure photographic evidence is authentic and not faked?</a:t>
+            </a:r>
+          </a:p>
+          <a:p>
+            <a:r>
+              <a:rPr b="1" sz="950">
+                <a:solidFill>
+                  <a:srgbClr val="166534"/>
+                </a:solidFill>
+              </a:rPr>
+              <a:t>Winning Answer: </a:t>
+            </a:r>
+            <a:r>
+              <a:rPr sz="900">
+                <a:solidFill>
+                  <a:srgbClr val="1E293B"/>
+                </a:solidFill>
+              </a:rPr>
+              <a:t>Strict Chain-of-Custody: (1) Direct Camera Hardware Binding capturing device sensor metadata, timestamps, and GPS geolocation; (2) Cryptographic SHA-256 Hashing: every photo is hashed immediately upon capture; (3) Immutable audit trail where any pixel modification breaks the hash.</a:t>
+            </a:r>
+          </a:p>
+        </p:txBody>
+      </p:sp>
+      <p:sp>
+        <p:nvSpPr>
+          <p:cNvPr id="6" name="Rounded Rectangle 5"/>
+          <p:cNvSpPr/>
+          <p:nvPr/>
+        </p:nvSpPr>
+        <p:spPr>
+          <a:xfrm>
+            <a:off x="457200" y="2834640"/>
+            <a:ext cx="11277295" cy="1691640"/>
+          </a:xfrm>
+          <a:prstGeom prst="roundRect">
+            <a:avLst/>
+          </a:prstGeom>
+          <a:solidFill>
+            <a:srgbClr val="F8FAFC"/>
+          </a:solidFill>
+          <a:ln w="12700">
+            <a:solidFill>
+              <a:srgbClr val="CBD5E1"/>
+            </a:solidFill>
+          </a:ln>
+        </p:spPr>
+        <p:style>
+          <a:lnRef idx="1">
+            <a:schemeClr val="accent1"/>
+          </a:lnRef>
+          <a:fillRef idx="3">
+            <a:schemeClr val="accent1"/>
+          </a:fillRef>
+          <a:effectRef idx="2">
+            <a:schemeClr val="accent1"/>
+          </a:effectRef>
+          <a:fontRef idx="minor">
+            <a:schemeClr val="lt1"/>
+          </a:fontRef>
+        </p:style>
+        <p:txBody>
+          <a:bodyPr rtlCol="0" anchor="ctr" wrap="square"/>
+          <a:lstStyle/>
+          <a:p>
+            <a:pPr algn="ctr">
+              <a:spcAft>
+                <a:spcPts val="300"/>
+              </a:spcAft>
+              <a:defRPr b="1" sz="1100">
+                <a:solidFill>
+                  <a:srgbClr val="1E3A8A"/>
+                </a:solidFill>
+              </a:defRPr>
+            </a:pPr>
+            <a:r>
+              <a:t>Q8: Can a corrupt inspector delete a violation after accepting a bribe?</a:t>
+            </a:r>
+          </a:p>
+          <a:p>
+            <a:r>
+              <a:rPr b="1" sz="950">
+                <a:solidFill>
+                  <a:srgbClr val="166534"/>
+                </a:solidFill>
+              </a:rPr>
+              <a:t>Winning Answer: </a:t>
+            </a:r>
+            <a:r>
+              <a:rPr sz="900">
+                <a:solidFill>
+                  <a:srgbClr val="1E293B"/>
+                </a:solidFill>
+              </a:rPr>
+              <a:t>No. All inspection scans and complaint records write to an Append-Only Immutable Audit Log. Once logged with AI-detected non-compliances, field inspectors cannot delete or silence records. Case reclassification requires senior official sign-off with mandatory statutory justification notes.</a:t>
+            </a:r>
+          </a:p>
+        </p:txBody>
+      </p:sp>
+      <p:sp>
+        <p:nvSpPr>
+          <p:cNvPr id="7" name="Rounded Rectangle 6"/>
+          <p:cNvSpPr/>
+          <p:nvPr/>
+        </p:nvSpPr>
+        <p:spPr>
+          <a:xfrm>
+            <a:off x="457200" y="4663440"/>
+            <a:ext cx="11277295" cy="1691640"/>
+          </a:xfrm>
+          <a:prstGeom prst="roundRect">
+            <a:avLst/>
+          </a:prstGeom>
+          <a:solidFill>
+            <a:srgbClr val="EFF6FF"/>
+          </a:solidFill>
+          <a:ln w="12700">
+            <a:solidFill>
+              <a:srgbClr val="2563EB"/>
+            </a:solidFill>
+          </a:ln>
+        </p:spPr>
+        <p:style>
+          <a:lnRef idx="1">
+            <a:schemeClr val="accent1"/>
+          </a:lnRef>
+          <a:fillRef idx="3">
+            <a:schemeClr val="accent1"/>
+          </a:fillRef>
+          <a:effectRef idx="2">
+            <a:schemeClr val="accent1"/>
+          </a:effectRef>
+          <a:fontRef idx="minor">
+            <a:schemeClr val="lt1"/>
+          </a:fontRef>
+        </p:style>
+        <p:txBody>
+          <a:bodyPr rtlCol="0" anchor="ctr" wrap="square"/>
+          <a:lstStyle/>
+          <a:p>
+            <a:pPr algn="ctr">
+              <a:spcAft>
+                <a:spcPts val="300"/>
+              </a:spcAft>
+              <a:defRPr b="1" sz="1100">
+                <a:solidFill>
+                  <a:srgbClr val="1E3A8A"/>
+                </a:solidFill>
+              </a:defRPr>
+            </a:pPr>
+            <a:r>
+              <a:t>Q9: What prevents citizens from accessing confidential officer investigation notes?</a:t>
+            </a:r>
+          </a:p>
+          <a:p>
+            <a:r>
+              <a:rPr b="1" sz="950">
+                <a:solidFill>
+                  <a:srgbClr val="166534"/>
+                </a:solidFill>
+              </a:rPr>
+              <a:t>Winning Answer: </a:t>
+            </a:r>
+            <a:r>
+              <a:rPr sz="900">
+                <a:solidFill>
+                  <a:srgbClr val="1E293B"/>
+                </a:solidFill>
+              </a:rPr>
+              <a:t>Role-Based Data Redaction on public endpoint (/track). Citizens see commodity name, date filed, and milestone progress, while internal officer investigation remarks, inspector phone numbers, and confidential compounding receipts are completely stripped.</a:t>
             </a:r>
           </a:p>
         </p:txBody>

</xml_diff>